<commit_message>
feat(harness): build_slides tool + book-slides skill; drug-information decks with explanations on slides
Co-Authored-By: Claude Opus 5.5 <noreply@anthropic.com>
</commit_message>
<xml_diff>
--- a/projects/drug-information-practical/slides/ch08-adr-causality-management.pptx
+++ b/projects/drug-information-practical/slides/ch08-adr-causality-management.pptx
@@ -4407,7 +4407,7 @@
             <a:r>
               <a:rPr sz="28000" i="0" b="1">
                 <a:solidFill>
-                  <a:srgbClr val="8C3A22"/>
+                  <a:srgbClr val="8B3C25"/>
                 </a:solidFill>
                 <a:latin typeface="Cambria"/>
               </a:rPr>
@@ -4500,7 +4500,7 @@
             <a:r>
               <a:rPr sz="1200" i="0" b="1" spc="200">
                 <a:solidFill>
-                  <a:srgbClr val="F3E6D8"/>
+                  <a:srgbClr val="F2E5E1"/>
                 </a:solidFill>
                 <a:latin typeface="Calibri"/>
               </a:rPr>
@@ -4534,7 +4534,7 @@
             <a:r>
               <a:rPr sz="1400" i="0" b="1" spc="200">
                 <a:solidFill>
-                  <a:srgbClr val="F3E6D8"/>
+                  <a:srgbClr val="F2E5E1"/>
                 </a:solidFill>
                 <a:latin typeface="Calibri"/>
               </a:rPr>
@@ -4566,7 +4566,7 @@
             <a:r>
               <a:rPr sz="2000" i="1" b="0">
                 <a:solidFill>
-                  <a:srgbClr val="F3E6D8"/>
+                  <a:srgbClr val="F2E5E1"/>
                 </a:solidFill>
                 <a:latin typeface="Cambria"/>
               </a:rPr>
@@ -4600,11 +4600,11 @@
             <a:r>
               <a:rPr sz="1300" i="0" b="0">
                 <a:solidFill>
-                  <a:srgbClr val="F3E6D8"/>
-                </a:solidFill>
-                <a:latin typeface="Calibri"/>
-              </a:rPr>
-              <a:t>45-minute practical section  ·  5 questions  ·  1 practice case</a:t>
+                  <a:srgbClr val="F2E5E1"/>
+                </a:solidFill>
+                <a:latin typeface="Calibri"/>
+              </a:rPr>
+              <a:t>45 minutes  ·  5 questions  ·  1 practice case</a:t>
             </a:r>
           </a:p>
         </p:txBody>
@@ -4672,7 +4672,7 @@
           </a:fontRef>
         </p:style>
         <p:txBody>
-          <a:bodyPr rtlCol="0" anchor="ctr" lIns="0" rIns="0"/>
+          <a:bodyPr rtlCol="0" anchor="ctr" lIns="0" rIns="0" tIns="0" bIns="0"/>
           <a:lstStyle/>
           <a:p>
             <a:pPr algn="ctr"/>
@@ -4851,20 +4851,120 @@
       </p:pic>
       <p:sp>
         <p:nvSpPr>
-          <p:cNvPr id="8" name="Oval 7"/>
+          <p:cNvPr id="8" name="TextBox 7"/>
+          <p:cNvSpPr txBox="1"/>
+          <p:nvPr/>
+        </p:nvSpPr>
+        <p:spPr>
+          <a:xfrm>
+            <a:off x="548640" y="1554480"/>
+            <a:ext cx="11094415" cy="1202436"/>
+          </a:xfrm>
+          <a:prstGeom prst="rect">
+            <a:avLst/>
+          </a:prstGeom>
+          <a:noFill/>
+        </p:spPr>
+        <p:txBody>
+          <a:bodyPr wrap="square" anchor="t" lIns="0" rIns="0" tIns="0" bIns="0">
+            <a:spAutoFit/>
+          </a:bodyPr>
+          <a:lstStyle/>
+          <a:p>
+            <a:pPr>
+              <a:spcAft>
+                <a:spcPts val="800"/>
+              </a:spcAft>
+            </a:pPr>
+            <a:r>
+              <a:rPr sz="1800" i="0" b="1">
+                <a:solidFill>
+                  <a:srgbClr val="2B211C"/>
+                </a:solidFill>
+                <a:latin typeface="Calibri"/>
+              </a:rPr>
+              <a:t>Seriousness</a:t>
+            </a:r>
+            <a:r>
+              <a:rPr sz="1800" i="0" b="0">
+                <a:solidFill>
+                  <a:srgbClr val="2B211C"/>
+                </a:solidFill>
+                <a:latin typeface="Calibri"/>
+              </a:rPr>
+              <a:t> is a regulatory term based on the </a:t>
+            </a:r>
+            <a:r>
+              <a:rPr sz="1800" i="0" b="1">
+                <a:solidFill>
+                  <a:srgbClr val="2B211C"/>
+                </a:solidFill>
+                <a:latin typeface="Calibri"/>
+              </a:rPr>
+              <a:t>outcome</a:t>
+            </a:r>
+            <a:r>
+              <a:rPr sz="1800" i="0" b="0">
+                <a:solidFill>
+                  <a:srgbClr val="2B211C"/>
+                </a:solidFill>
+                <a:latin typeface="Calibri"/>
+              </a:rPr>
+              <a:t>. An ADR is </a:t>
+            </a:r>
+            <a:r>
+              <a:rPr sz="1800" i="0" b="1">
+                <a:solidFill>
+                  <a:srgbClr val="2B211C"/>
+                </a:solidFill>
+                <a:latin typeface="Calibri"/>
+              </a:rPr>
+              <a:t>serious</a:t>
+            </a:r>
+            <a:r>
+              <a:rPr sz="1800" i="0" b="0">
+                <a:solidFill>
+                  <a:srgbClr val="2B211C"/>
+                </a:solidFill>
+                <a:latin typeface="Calibri"/>
+              </a:rPr>
+              <a:t> if it:</a:t>
+            </a:r>
+          </a:p>
+          <a:p>
+            <a:pPr>
+              <a:spcAft>
+                <a:spcPts val="800"/>
+              </a:spcAft>
+            </a:pPr>
+            <a:r>
+              <a:rPr sz="1800" i="0" b="0">
+                <a:solidFill>
+                  <a:srgbClr val="2B211C"/>
+                </a:solidFill>
+                <a:latin typeface="Calibri"/>
+              </a:rPr>
+              <a:t>A severe headache is intense but usually not serious. Serious reactions must be reported quickly (Chapter 9).</a:t>
+            </a:r>
+          </a:p>
+        </p:txBody>
+      </p:sp>
+      <p:sp>
+        <p:nvSpPr>
+          <p:cNvPr id="9" name="Oval 8"/>
           <p:cNvSpPr/>
           <p:nvPr/>
         </p:nvSpPr>
         <p:spPr>
           <a:xfrm>
-            <a:off x="548640" y="1618488"/>
+            <a:off x="548640" y="2958084"/>
             <a:ext cx="402336" cy="402336"/>
           </a:xfrm>
           <a:prstGeom prst="ellipse">
             <a:avLst/>
           </a:prstGeom>
           <a:solidFill>
-            <a:srgbClr val="E0EEF0"/>
+            <a:srgbClr val="E6EEEF"/>
           </a:solidFill>
           <a:ln>
             <a:noFill/>
@@ -4886,7 +4986,7 @@
           </a:fontRef>
         </p:style>
         <p:txBody>
-          <a:bodyPr rtlCol="0" anchor="ctr" lIns="0" rIns="0"/>
+          <a:bodyPr rtlCol="0" anchor="ctr" lIns="0" rIns="0" tIns="0" bIns="0"/>
           <a:lstStyle/>
           <a:p>
             <a:pPr algn="ctr"/>
@@ -4904,14 +5004,14 @@
       </p:sp>
       <p:sp>
         <p:nvSpPr>
-          <p:cNvPr id="9" name="TextBox 8"/>
+          <p:cNvPr id="10" name="TextBox 9"/>
           <p:cNvSpPr txBox="1"/>
           <p:nvPr/>
         </p:nvSpPr>
         <p:spPr>
           <a:xfrm>
-            <a:off x="1143000" y="1636776"/>
-            <a:ext cx="10500055" cy="708660"/>
+            <a:off x="1143000" y="2976372"/>
+            <a:ext cx="10500055" cy="493014"/>
           </a:xfrm>
           <a:prstGeom prst="rect">
             <a:avLst/>
@@ -4938,20 +5038,20 @@
       </p:sp>
       <p:sp>
         <p:nvSpPr>
-          <p:cNvPr id="10" name="Oval 9"/>
+          <p:cNvPr id="11" name="Oval 10"/>
           <p:cNvSpPr/>
           <p:nvPr/>
         </p:nvSpPr>
         <p:spPr>
           <a:xfrm>
-            <a:off x="548640" y="2372868"/>
+            <a:off x="548640" y="3496818"/>
             <a:ext cx="402336" cy="402336"/>
           </a:xfrm>
           <a:prstGeom prst="ellipse">
             <a:avLst/>
           </a:prstGeom>
           <a:solidFill>
-            <a:srgbClr val="E0EEF0"/>
+            <a:srgbClr val="E6EEEF"/>
           </a:solidFill>
           <a:ln>
             <a:noFill/>
@@ -4973,7 +5073,7 @@
           </a:fontRef>
         </p:style>
         <p:txBody>
-          <a:bodyPr rtlCol="0" anchor="ctr" lIns="0" rIns="0"/>
+          <a:bodyPr rtlCol="0" anchor="ctr" lIns="0" rIns="0" tIns="0" bIns="0"/>
           <a:lstStyle/>
           <a:p>
             <a:pPr algn="ctr"/>
@@ -4991,14 +5091,14 @@
       </p:sp>
       <p:sp>
         <p:nvSpPr>
-          <p:cNvPr id="11" name="TextBox 10"/>
+          <p:cNvPr id="12" name="TextBox 11"/>
           <p:cNvSpPr txBox="1"/>
           <p:nvPr/>
         </p:nvSpPr>
         <p:spPr>
           <a:xfrm>
-            <a:off x="1143000" y="2391156"/>
-            <a:ext cx="10500055" cy="708660"/>
+            <a:off x="1143000" y="3515106"/>
+            <a:ext cx="10500055" cy="493014"/>
           </a:xfrm>
           <a:prstGeom prst="rect">
             <a:avLst/>
@@ -5025,20 +5125,20 @@
       </p:sp>
       <p:sp>
         <p:nvSpPr>
-          <p:cNvPr id="12" name="Oval 11"/>
+          <p:cNvPr id="13" name="Oval 12"/>
           <p:cNvSpPr/>
           <p:nvPr/>
         </p:nvSpPr>
         <p:spPr>
           <a:xfrm>
-            <a:off x="548640" y="3127248"/>
+            <a:off x="548640" y="4035552"/>
             <a:ext cx="402336" cy="402336"/>
           </a:xfrm>
           <a:prstGeom prst="ellipse">
             <a:avLst/>
           </a:prstGeom>
           <a:solidFill>
-            <a:srgbClr val="E0EEF0"/>
+            <a:srgbClr val="E6EEEF"/>
           </a:solidFill>
           <a:ln>
             <a:noFill/>
@@ -5060,7 +5160,7 @@
           </a:fontRef>
         </p:style>
         <p:txBody>
-          <a:bodyPr rtlCol="0" anchor="ctr" lIns="0" rIns="0"/>
+          <a:bodyPr rtlCol="0" anchor="ctr" lIns="0" rIns="0" tIns="0" bIns="0"/>
           <a:lstStyle/>
           <a:p>
             <a:pPr algn="ctr"/>
@@ -5078,14 +5178,14 @@
       </p:sp>
       <p:sp>
         <p:nvSpPr>
-          <p:cNvPr id="13" name="TextBox 12"/>
+          <p:cNvPr id="14" name="TextBox 13"/>
           <p:cNvSpPr txBox="1"/>
           <p:nvPr/>
         </p:nvSpPr>
         <p:spPr>
           <a:xfrm>
-            <a:off x="1143000" y="3145536"/>
-            <a:ext cx="10500055" cy="708660"/>
+            <a:off x="1143000" y="4053840"/>
+            <a:ext cx="10500055" cy="493014"/>
           </a:xfrm>
           <a:prstGeom prst="rect">
             <a:avLst/>
@@ -5112,20 +5212,20 @@
       </p:sp>
       <p:sp>
         <p:nvSpPr>
-          <p:cNvPr id="14" name="Oval 13"/>
+          <p:cNvPr id="15" name="Oval 14"/>
           <p:cNvSpPr/>
           <p:nvPr/>
         </p:nvSpPr>
         <p:spPr>
           <a:xfrm>
-            <a:off x="548640" y="3881628"/>
+            <a:off x="548640" y="4574286"/>
             <a:ext cx="402336" cy="402336"/>
           </a:xfrm>
           <a:prstGeom prst="ellipse">
             <a:avLst/>
           </a:prstGeom>
           <a:solidFill>
-            <a:srgbClr val="E0EEF0"/>
+            <a:srgbClr val="E6EEEF"/>
           </a:solidFill>
           <a:ln>
             <a:noFill/>
@@ -5147,7 +5247,7 @@
           </a:fontRef>
         </p:style>
         <p:txBody>
-          <a:bodyPr rtlCol="0" anchor="ctr" lIns="0" rIns="0"/>
+          <a:bodyPr rtlCol="0" anchor="ctr" lIns="0" rIns="0" tIns="0" bIns="0"/>
           <a:lstStyle/>
           <a:p>
             <a:pPr algn="ctr"/>
@@ -5165,14 +5265,14 @@
       </p:sp>
       <p:sp>
         <p:nvSpPr>
-          <p:cNvPr id="15" name="TextBox 14"/>
+          <p:cNvPr id="16" name="TextBox 15"/>
           <p:cNvSpPr txBox="1"/>
           <p:nvPr/>
         </p:nvSpPr>
         <p:spPr>
           <a:xfrm>
-            <a:off x="1143000" y="3899916"/>
-            <a:ext cx="10500055" cy="708660"/>
+            <a:off x="1143000" y="4592574"/>
+            <a:ext cx="10500055" cy="493014"/>
           </a:xfrm>
           <a:prstGeom prst="rect">
             <a:avLst/>
@@ -5199,20 +5299,20 @@
       </p:sp>
       <p:sp>
         <p:nvSpPr>
-          <p:cNvPr id="16" name="Oval 15"/>
+          <p:cNvPr id="17" name="Oval 16"/>
           <p:cNvSpPr/>
           <p:nvPr/>
         </p:nvSpPr>
         <p:spPr>
           <a:xfrm>
-            <a:off x="548640" y="4636008"/>
+            <a:off x="548640" y="5113019"/>
             <a:ext cx="402336" cy="402336"/>
           </a:xfrm>
           <a:prstGeom prst="ellipse">
             <a:avLst/>
           </a:prstGeom>
           <a:solidFill>
-            <a:srgbClr val="E0EEF0"/>
+            <a:srgbClr val="E6EEEF"/>
           </a:solidFill>
           <a:ln>
             <a:noFill/>
@@ -5234,7 +5334,7 @@
           </a:fontRef>
         </p:style>
         <p:txBody>
-          <a:bodyPr rtlCol="0" anchor="ctr" lIns="0" rIns="0"/>
+          <a:bodyPr rtlCol="0" anchor="ctr" lIns="0" rIns="0" tIns="0" bIns="0"/>
           <a:lstStyle/>
           <a:p>
             <a:pPr algn="ctr"/>
@@ -5252,14 +5352,14 @@
       </p:sp>
       <p:sp>
         <p:nvSpPr>
-          <p:cNvPr id="17" name="TextBox 16"/>
+          <p:cNvPr id="18" name="TextBox 17"/>
           <p:cNvSpPr txBox="1"/>
           <p:nvPr/>
         </p:nvSpPr>
         <p:spPr>
           <a:xfrm>
-            <a:off x="1143000" y="4654296"/>
-            <a:ext cx="10500055" cy="708660"/>
+            <a:off x="1143000" y="5131308"/>
+            <a:ext cx="10500055" cy="493014"/>
           </a:xfrm>
           <a:prstGeom prst="rect">
             <a:avLst/>
@@ -5286,20 +5386,20 @@
       </p:sp>
       <p:sp>
         <p:nvSpPr>
-          <p:cNvPr id="18" name="Oval 17"/>
+          <p:cNvPr id="19" name="Oval 18"/>
           <p:cNvSpPr/>
           <p:nvPr/>
         </p:nvSpPr>
         <p:spPr>
           <a:xfrm>
-            <a:off x="548640" y="5390388"/>
+            <a:off x="548640" y="5651753"/>
             <a:ext cx="402336" cy="402336"/>
           </a:xfrm>
           <a:prstGeom prst="ellipse">
             <a:avLst/>
           </a:prstGeom>
           <a:solidFill>
-            <a:srgbClr val="E0EEF0"/>
+            <a:srgbClr val="E6EEEF"/>
           </a:solidFill>
           <a:ln>
             <a:noFill/>
@@ -5321,7 +5421,7 @@
           </a:fontRef>
         </p:style>
         <p:txBody>
-          <a:bodyPr rtlCol="0" anchor="ctr" lIns="0" rIns="0"/>
+          <a:bodyPr rtlCol="0" anchor="ctr" lIns="0" rIns="0" tIns="0" bIns="0"/>
           <a:lstStyle/>
           <a:p>
             <a:pPr algn="ctr"/>
@@ -5339,14 +5439,14 @@
       </p:sp>
       <p:sp>
         <p:nvSpPr>
-          <p:cNvPr id="19" name="TextBox 18"/>
+          <p:cNvPr id="20" name="TextBox 19"/>
           <p:cNvSpPr txBox="1"/>
           <p:nvPr/>
         </p:nvSpPr>
         <p:spPr>
           <a:xfrm>
-            <a:off x="1143000" y="5408676"/>
-            <a:ext cx="10500055" cy="708660"/>
+            <a:off x="1143000" y="5670041"/>
+            <a:ext cx="10500055" cy="493014"/>
           </a:xfrm>
           <a:prstGeom prst="rect">
             <a:avLst/>
@@ -5434,7 +5534,7 @@
           </a:fontRef>
         </p:style>
         <p:txBody>
-          <a:bodyPr rtlCol="0" anchor="ctr" lIns="0" rIns="0"/>
+          <a:bodyPr rtlCol="0" anchor="ctr" lIns="0" rIns="0" tIns="0" bIns="0"/>
           <a:lstStyle/>
           <a:p>
             <a:pPr algn="ctr"/>
@@ -5627,8 +5727,8 @@
         </p:blipFill>
         <p:spPr>
           <a:xfrm>
-            <a:off x="1638917" y="1554480"/>
-            <a:ext cx="8913860" cy="4160520"/>
+            <a:off x="1589940" y="1554480"/>
+            <a:ext cx="9011814" cy="4206240"/>
           </a:xfrm>
           <a:prstGeom prst="rect">
             <a:avLst/>
@@ -5643,7 +5743,7 @@
         </p:nvSpPr>
         <p:spPr>
           <a:xfrm>
-            <a:off x="548640" y="5852160"/>
+            <a:off x="548640" y="5852159"/>
             <a:ext cx="11094415" cy="365760"/>
           </a:xfrm>
           <a:prstGeom prst="rect">
@@ -5733,7 +5833,7 @@
           </a:fontRef>
         </p:style>
         <p:txBody>
-          <a:bodyPr rtlCol="0" anchor="ctr" lIns="0" rIns="0"/>
+          <a:bodyPr rtlCol="0" anchor="ctr" lIns="0" rIns="0" tIns="0" bIns="0"/>
           <a:lstStyle/>
           <a:p>
             <a:pPr algn="ctr"/>
@@ -5918,14 +6018,14 @@
         </p:nvSpPr>
         <p:spPr>
           <a:xfrm>
-            <a:off x="548640" y="1618488"/>
+            <a:off x="548640" y="1572768"/>
             <a:ext cx="402336" cy="402336"/>
           </a:xfrm>
           <a:prstGeom prst="ellipse">
             <a:avLst/>
           </a:prstGeom>
           <a:solidFill>
-            <a:srgbClr val="E0EEF0"/>
+            <a:srgbClr val="E6EEEF"/>
           </a:solidFill>
           <a:ln>
             <a:noFill/>
@@ -5947,7 +6047,7 @@
           </a:fontRef>
         </p:style>
         <p:txBody>
-          <a:bodyPr rtlCol="0" anchor="ctr" lIns="0" rIns="0"/>
+          <a:bodyPr rtlCol="0" anchor="ctr" lIns="0" rIns="0" tIns="0" bIns="0"/>
           <a:lstStyle/>
           <a:p>
             <a:pPr algn="ctr"/>
@@ -5971,8 +6071,8 @@
         </p:nvSpPr>
         <p:spPr>
           <a:xfrm>
-            <a:off x="1143000" y="1636776"/>
-            <a:ext cx="10500055" cy="1030986"/>
+            <a:off x="1143000" y="1591056"/>
+            <a:ext cx="10500055" cy="1049274"/>
           </a:xfrm>
           <a:prstGeom prst="rect">
             <a:avLst/>
@@ -6014,14 +6114,14 @@
         </p:nvSpPr>
         <p:spPr>
           <a:xfrm>
-            <a:off x="548640" y="2695194"/>
+            <a:off x="548640" y="2667762"/>
             <a:ext cx="402336" cy="402336"/>
           </a:xfrm>
           <a:prstGeom prst="ellipse">
             <a:avLst/>
           </a:prstGeom>
           <a:solidFill>
-            <a:srgbClr val="E0EEF0"/>
+            <a:srgbClr val="E6EEEF"/>
           </a:solidFill>
           <a:ln>
             <a:noFill/>
@@ -6043,7 +6143,7 @@
           </a:fontRef>
         </p:style>
         <p:txBody>
-          <a:bodyPr rtlCol="0" anchor="ctr" lIns="0" rIns="0"/>
+          <a:bodyPr rtlCol="0" anchor="ctr" lIns="0" rIns="0" tIns="0" bIns="0"/>
           <a:lstStyle/>
           <a:p>
             <a:pPr algn="ctr"/>
@@ -6067,8 +6167,8 @@
         </p:nvSpPr>
         <p:spPr>
           <a:xfrm>
-            <a:off x="1143000" y="2713482"/>
-            <a:ext cx="10500055" cy="745236"/>
+            <a:off x="1143000" y="2686050"/>
+            <a:ext cx="10500055" cy="763524"/>
           </a:xfrm>
           <a:prstGeom prst="rect">
             <a:avLst/>
@@ -6110,14 +6210,14 @@
         </p:nvSpPr>
         <p:spPr>
           <a:xfrm>
-            <a:off x="548640" y="3486150"/>
+            <a:off x="548640" y="3477006"/>
             <a:ext cx="402336" cy="402336"/>
           </a:xfrm>
           <a:prstGeom prst="ellipse">
             <a:avLst/>
           </a:prstGeom>
           <a:solidFill>
-            <a:srgbClr val="E0EEF0"/>
+            <a:srgbClr val="E6EEEF"/>
           </a:solidFill>
           <a:ln>
             <a:noFill/>
@@ -6139,7 +6239,7 @@
           </a:fontRef>
         </p:style>
         <p:txBody>
-          <a:bodyPr rtlCol="0" anchor="ctr" lIns="0" rIns="0"/>
+          <a:bodyPr rtlCol="0" anchor="ctr" lIns="0" rIns="0" tIns="0" bIns="0"/>
           <a:lstStyle/>
           <a:p>
             <a:pPr algn="ctr"/>
@@ -6163,8 +6263,8 @@
         </p:nvSpPr>
         <p:spPr>
           <a:xfrm>
-            <a:off x="1143000" y="3504438"/>
-            <a:ext cx="10500055" cy="745236"/>
+            <a:off x="1143000" y="3495294"/>
+            <a:ext cx="10500055" cy="763524"/>
           </a:xfrm>
           <a:prstGeom prst="rect">
             <a:avLst/>
@@ -6206,14 +6306,14 @@
         </p:nvSpPr>
         <p:spPr>
           <a:xfrm>
-            <a:off x="548640" y="4277106"/>
+            <a:off x="548640" y="4286249"/>
             <a:ext cx="402336" cy="402336"/>
           </a:xfrm>
           <a:prstGeom prst="ellipse">
             <a:avLst/>
           </a:prstGeom>
           <a:solidFill>
-            <a:srgbClr val="E0EEF0"/>
+            <a:srgbClr val="E6EEEF"/>
           </a:solidFill>
           <a:ln>
             <a:noFill/>
@@ -6235,7 +6335,7 @@
           </a:fontRef>
         </p:style>
         <p:txBody>
-          <a:bodyPr rtlCol="0" anchor="ctr" lIns="0" rIns="0"/>
+          <a:bodyPr rtlCol="0" anchor="ctr" lIns="0" rIns="0" tIns="0" bIns="0"/>
           <a:lstStyle/>
           <a:p>
             <a:pPr algn="ctr"/>
@@ -6259,8 +6359,8 @@
         </p:nvSpPr>
         <p:spPr>
           <a:xfrm>
-            <a:off x="1143000" y="4295394"/>
-            <a:ext cx="10500055" cy="745236"/>
+            <a:off x="1143000" y="4304538"/>
+            <a:ext cx="10500055" cy="763524"/>
           </a:xfrm>
           <a:prstGeom prst="rect">
             <a:avLst/>
@@ -6302,14 +6402,14 @@
         </p:nvSpPr>
         <p:spPr>
           <a:xfrm>
-            <a:off x="548640" y="5068062"/>
+            <a:off x="548640" y="5095493"/>
             <a:ext cx="402336" cy="402336"/>
           </a:xfrm>
           <a:prstGeom prst="ellipse">
             <a:avLst/>
           </a:prstGeom>
           <a:solidFill>
-            <a:srgbClr val="E0EEF0"/>
+            <a:srgbClr val="E6EEEF"/>
           </a:solidFill>
           <a:ln>
             <a:noFill/>
@@ -6331,7 +6431,7 @@
           </a:fontRef>
         </p:style>
         <p:txBody>
-          <a:bodyPr rtlCol="0" anchor="ctr" lIns="0" rIns="0"/>
+          <a:bodyPr rtlCol="0" anchor="ctr" lIns="0" rIns="0" tIns="0" bIns="0"/>
           <a:lstStyle/>
           <a:p>
             <a:pPr algn="ctr"/>
@@ -6355,8 +6455,8 @@
         </p:nvSpPr>
         <p:spPr>
           <a:xfrm>
-            <a:off x="1143000" y="5086350"/>
-            <a:ext cx="10500055" cy="1030986"/>
+            <a:off x="1143000" y="5113781"/>
+            <a:ext cx="10500055" cy="1049274"/>
           </a:xfrm>
           <a:prstGeom prst="rect">
             <a:avLst/>
@@ -6453,7 +6553,7 @@
           </a:fontRef>
         </p:style>
         <p:txBody>
-          <a:bodyPr rtlCol="0" anchor="ctr" lIns="0" rIns="0"/>
+          <a:bodyPr rtlCol="0" anchor="ctr" lIns="0" rIns="0" tIns="0" bIns="0"/>
           <a:lstStyle/>
           <a:p>
             <a:pPr algn="ctr"/>
@@ -6720,7 +6820,7 @@
           <a:p>
             <a:pPr algn="ctr"/>
             <a:r>
-              <a:rPr sz="1050" i="0" b="1" spc="100">
+              <a:rPr sz="1050" i="0" b="1">
                 <a:solidFill>
                   <a:srgbClr val="FFFFFF"/>
                 </a:solidFill>
@@ -6857,11 +6957,10 @@
           </a:bodyPr>
           <a:lstStyle/>
           <a:p>
-            <a:pPr algn="l"/>
             <a:r>
               <a:rPr sz="13000" i="0" b="1">
                 <a:solidFill>
-                  <a:srgbClr val="E0EEF0"/>
+                  <a:srgbClr val="E6EEEF"/>
                 </a:solidFill>
                 <a:latin typeface="Cambria"/>
               </a:rPr>
@@ -6906,7 +7005,7 @@
             <a:r>
               <a:rPr sz="1400" i="0" b="1" spc="150">
                 <a:solidFill>
-                  <a:srgbClr val="E0EEF0"/>
+                  <a:srgbClr val="E6EEEF"/>
                 </a:solidFill>
                 <a:latin typeface="Calibri"/>
               </a:rPr>
@@ -6958,7 +7057,7 @@
         <p:spPr>
           <a:xfrm>
             <a:off x="4526280" y="6419088"/>
-            <a:ext cx="5486400" cy="274320"/>
+            <a:ext cx="8229600" cy="274320"/>
           </a:xfrm>
           <a:prstGeom prst="rect">
             <a:avLst/>
@@ -7105,7 +7204,7 @@
           </a:fontRef>
         </p:style>
         <p:txBody>
-          <a:bodyPr rtlCol="0" anchor="ctr" lIns="0" rIns="0"/>
+          <a:bodyPr rtlCol="0" anchor="ctr" lIns="0" rIns="0" tIns="0" bIns="0"/>
           <a:lstStyle/>
           <a:p>
             <a:pPr algn="ctr"/>
@@ -7150,7 +7249,7 @@
                 </a:solidFill>
                 <a:latin typeface="Calibri"/>
               </a:rPr>
-              <a:t>SELF-ASSESSMENT  ·  QUESTION 1 OF 5</a:t>
+              <a:t>SECTION 8  ·  QUESTION 1 OF 5</a:t>
             </a:r>
           </a:p>
         </p:txBody>
@@ -7333,7 +7432,7 @@
             </a:avLst>
           </a:prstGeom>
           <a:solidFill>
-            <a:srgbClr val="FBF3EE"/>
+            <a:srgbClr val="FAF4F2"/>
           </a:solidFill>
           <a:ln>
             <a:noFill/>
@@ -7399,7 +7498,7 @@
           </a:fontRef>
         </p:style>
         <p:txBody>
-          <a:bodyPr rtlCol="0" anchor="ctr" lIns="0" rIns="0"/>
+          <a:bodyPr rtlCol="0" anchor="ctr" lIns="0" rIns="0" tIns="0" bIns="0"/>
           <a:lstStyle/>
           <a:p>
             <a:pPr algn="ctr"/>
@@ -7466,7 +7565,7 @@
             </a:avLst>
           </a:prstGeom>
           <a:solidFill>
-            <a:srgbClr val="FBF3EE"/>
+            <a:srgbClr val="FAF4F2"/>
           </a:solidFill>
           <a:ln>
             <a:noFill/>
@@ -7532,7 +7631,7 @@
           </a:fontRef>
         </p:style>
         <p:txBody>
-          <a:bodyPr rtlCol="0" anchor="ctr" lIns="0" rIns="0"/>
+          <a:bodyPr rtlCol="0" anchor="ctr" lIns="0" rIns="0" tIns="0" bIns="0"/>
           <a:lstStyle/>
           <a:p>
             <a:pPr algn="ctr"/>
@@ -7599,7 +7698,7 @@
             </a:avLst>
           </a:prstGeom>
           <a:solidFill>
-            <a:srgbClr val="FBF3EE"/>
+            <a:srgbClr val="FAF4F2"/>
           </a:solidFill>
           <a:ln>
             <a:noFill/>
@@ -7665,7 +7764,7 @@
           </a:fontRef>
         </p:style>
         <p:txBody>
-          <a:bodyPr rtlCol="0" anchor="ctr" lIns="0" rIns="0"/>
+          <a:bodyPr rtlCol="0" anchor="ctr" lIns="0" rIns="0" tIns="0" bIns="0"/>
           <a:lstStyle/>
           <a:p>
             <a:pPr algn="ctr"/>
@@ -7732,7 +7831,7 @@
             </a:avLst>
           </a:prstGeom>
           <a:solidFill>
-            <a:srgbClr val="FBF3EE"/>
+            <a:srgbClr val="FAF4F2"/>
           </a:solidFill>
           <a:ln>
             <a:noFill/>
@@ -7798,7 +7897,7 @@
           </a:fontRef>
         </p:style>
         <p:txBody>
-          <a:bodyPr rtlCol="0" anchor="ctr" lIns="0" rIns="0"/>
+          <a:bodyPr rtlCol="0" anchor="ctr" lIns="0" rIns="0" tIns="0" bIns="0"/>
           <a:lstStyle/>
           <a:p>
             <a:pPr algn="ctr"/>
@@ -7911,7 +8010,7 @@
           </a:fontRef>
         </p:style>
         <p:txBody>
-          <a:bodyPr rtlCol="0" anchor="ctr" lIns="0" rIns="0"/>
+          <a:bodyPr rtlCol="0" anchor="ctr" lIns="0" rIns="0" tIns="0" bIns="0"/>
           <a:lstStyle/>
           <a:p>
             <a:pPr algn="ctr"/>
@@ -7956,7 +8055,7 @@
                 </a:solidFill>
                 <a:latin typeface="Calibri"/>
               </a:rPr>
-              <a:t>SELF-ASSESSMENT  ·  QUESTION 1 OF 5  ·  ANSWER</a:t>
+              <a:t>SECTION 8  ·  QUESTION 1 OF 5  ·  ANSWER</a:t>
             </a:r>
           </a:p>
         </p:txBody>
@@ -8139,7 +8238,7 @@
             </a:avLst>
           </a:prstGeom>
           <a:solidFill>
-            <a:srgbClr val="F7F4F2"/>
+            <a:srgbClr val="F5F4F4"/>
           </a:solidFill>
           <a:ln>
             <a:noFill/>
@@ -8183,7 +8282,7 @@
             <a:avLst/>
           </a:prstGeom>
           <a:solidFill>
-            <a:srgbClr val="E6DFDA"/>
+            <a:srgbClr val="E2E0DE"/>
           </a:solidFill>
           <a:ln>
             <a:noFill/>
@@ -8205,7 +8304,7 @@
           </a:fontRef>
         </p:style>
         <p:txBody>
-          <a:bodyPr rtlCol="0" anchor="ctr" lIns="0" rIns="0"/>
+          <a:bodyPr rtlCol="0" anchor="ctr" lIns="0" rIns="0" tIns="0" bIns="0"/>
           <a:lstStyle/>
           <a:p>
             <a:pPr algn="ctr"/>
@@ -8272,7 +8371,7 @@
             </a:avLst>
           </a:prstGeom>
           <a:solidFill>
-            <a:srgbClr val="F7F4F2"/>
+            <a:srgbClr val="F5F4F4"/>
           </a:solidFill>
           <a:ln>
             <a:noFill/>
@@ -8316,7 +8415,7 @@
             <a:avLst/>
           </a:prstGeom>
           <a:solidFill>
-            <a:srgbClr val="E6DFDA"/>
+            <a:srgbClr val="E2E0DE"/>
           </a:solidFill>
           <a:ln>
             <a:noFill/>
@@ -8338,7 +8437,7 @@
           </a:fontRef>
         </p:style>
         <p:txBody>
-          <a:bodyPr rtlCol="0" anchor="ctr" lIns="0" rIns="0"/>
+          <a:bodyPr rtlCol="0" anchor="ctr" lIns="0" rIns="0" tIns="0" bIns="0"/>
           <a:lstStyle/>
           <a:p>
             <a:pPr algn="ctr"/>
@@ -8471,7 +8570,7 @@
           </a:fontRef>
         </p:style>
         <p:txBody>
-          <a:bodyPr rtlCol="0" anchor="ctr" lIns="0" rIns="0"/>
+          <a:bodyPr rtlCol="0" anchor="ctr" lIns="0" rIns="0" tIns="0" bIns="0"/>
           <a:lstStyle/>
           <a:p>
             <a:pPr algn="ctr"/>
@@ -8538,7 +8637,7 @@
             </a:avLst>
           </a:prstGeom>
           <a:solidFill>
-            <a:srgbClr val="F7F4F2"/>
+            <a:srgbClr val="F5F4F4"/>
           </a:solidFill>
           <a:ln>
             <a:noFill/>
@@ -8582,7 +8681,7 @@
             <a:avLst/>
           </a:prstGeom>
           <a:solidFill>
-            <a:srgbClr val="E6DFDA"/>
+            <a:srgbClr val="E2E0DE"/>
           </a:solidFill>
           <a:ln>
             <a:noFill/>
@@ -8604,7 +8703,7 @@
           </a:fontRef>
         </p:style>
         <p:txBody>
-          <a:bodyPr rtlCol="0" anchor="ctr" lIns="0" rIns="0"/>
+          <a:bodyPr rtlCol="0" anchor="ctr" lIns="0" rIns="0" tIns="0" bIns="0"/>
           <a:lstStyle/>
           <a:p>
             <a:pPr algn="ctr"/>
@@ -8760,7 +8859,7 @@
           </a:fontRef>
         </p:style>
         <p:txBody>
-          <a:bodyPr rtlCol="0" anchor="ctr" lIns="0" rIns="0"/>
+          <a:bodyPr rtlCol="0" anchor="ctr" lIns="0" rIns="0" tIns="0" bIns="0"/>
           <a:lstStyle/>
           <a:p>
             <a:pPr algn="ctr"/>
@@ -8805,7 +8904,7 @@
                 </a:solidFill>
                 <a:latin typeface="Calibri"/>
               </a:rPr>
-              <a:t>SELF-ASSESSMENT  ·  QUESTION 2 OF 5</a:t>
+              <a:t>SECTION 8  ·  QUESTION 2 OF 5</a:t>
             </a:r>
           </a:p>
         </p:txBody>
@@ -8988,7 +9087,7 @@
             </a:avLst>
           </a:prstGeom>
           <a:solidFill>
-            <a:srgbClr val="FBF3EE"/>
+            <a:srgbClr val="FAF4F2"/>
           </a:solidFill>
           <a:ln>
             <a:noFill/>
@@ -9054,7 +9153,7 @@
           </a:fontRef>
         </p:style>
         <p:txBody>
-          <a:bodyPr rtlCol="0" anchor="ctr" lIns="0" rIns="0"/>
+          <a:bodyPr rtlCol="0" anchor="ctr" lIns="0" rIns="0" tIns="0" bIns="0"/>
           <a:lstStyle/>
           <a:p>
             <a:pPr algn="ctr"/>
@@ -9121,7 +9220,7 @@
             </a:avLst>
           </a:prstGeom>
           <a:solidFill>
-            <a:srgbClr val="FBF3EE"/>
+            <a:srgbClr val="FAF4F2"/>
           </a:solidFill>
           <a:ln>
             <a:noFill/>
@@ -9187,7 +9286,7 @@
           </a:fontRef>
         </p:style>
         <p:txBody>
-          <a:bodyPr rtlCol="0" anchor="ctr" lIns="0" rIns="0"/>
+          <a:bodyPr rtlCol="0" anchor="ctr" lIns="0" rIns="0" tIns="0" bIns="0"/>
           <a:lstStyle/>
           <a:p>
             <a:pPr algn="ctr"/>
@@ -9254,7 +9353,7 @@
             </a:avLst>
           </a:prstGeom>
           <a:solidFill>
-            <a:srgbClr val="FBF3EE"/>
+            <a:srgbClr val="FAF4F2"/>
           </a:solidFill>
           <a:ln>
             <a:noFill/>
@@ -9320,7 +9419,7 @@
           </a:fontRef>
         </p:style>
         <p:txBody>
-          <a:bodyPr rtlCol="0" anchor="ctr" lIns="0" rIns="0"/>
+          <a:bodyPr rtlCol="0" anchor="ctr" lIns="0" rIns="0" tIns="0" bIns="0"/>
           <a:lstStyle/>
           <a:p>
             <a:pPr algn="ctr"/>
@@ -9387,7 +9486,7 @@
             </a:avLst>
           </a:prstGeom>
           <a:solidFill>
-            <a:srgbClr val="FBF3EE"/>
+            <a:srgbClr val="FAF4F2"/>
           </a:solidFill>
           <a:ln>
             <a:noFill/>
@@ -9453,7 +9552,7 @@
           </a:fontRef>
         </p:style>
         <p:txBody>
-          <a:bodyPr rtlCol="0" anchor="ctr" lIns="0" rIns="0"/>
+          <a:bodyPr rtlCol="0" anchor="ctr" lIns="0" rIns="0" tIns="0" bIns="0"/>
           <a:lstStyle/>
           <a:p>
             <a:pPr algn="ctr"/>
@@ -9566,7 +9665,7 @@
           </a:fontRef>
         </p:style>
         <p:txBody>
-          <a:bodyPr rtlCol="0" anchor="ctr" lIns="0" rIns="0"/>
+          <a:bodyPr rtlCol="0" anchor="ctr" lIns="0" rIns="0" tIns="0" bIns="0"/>
           <a:lstStyle/>
           <a:p>
             <a:pPr algn="ctr"/>
@@ -9611,7 +9710,7 @@
                 </a:solidFill>
                 <a:latin typeface="Calibri"/>
               </a:rPr>
-              <a:t>SELF-ASSESSMENT  ·  QUESTION 2 OF 5  ·  ANSWER</a:t>
+              <a:t>SECTION 8  ·  QUESTION 2 OF 5  ·  ANSWER</a:t>
             </a:r>
           </a:p>
         </p:txBody>
@@ -9860,7 +9959,7 @@
           </a:fontRef>
         </p:style>
         <p:txBody>
-          <a:bodyPr rtlCol="0" anchor="ctr" lIns="0" rIns="0"/>
+          <a:bodyPr rtlCol="0" anchor="ctr" lIns="0" rIns="0" tIns="0" bIns="0"/>
           <a:lstStyle/>
           <a:p>
             <a:pPr algn="ctr"/>
@@ -9927,7 +10026,7 @@
             </a:avLst>
           </a:prstGeom>
           <a:solidFill>
-            <a:srgbClr val="F7F4F2"/>
+            <a:srgbClr val="F5F4F4"/>
           </a:solidFill>
           <a:ln>
             <a:noFill/>
@@ -9971,7 +10070,7 @@
             <a:avLst/>
           </a:prstGeom>
           <a:solidFill>
-            <a:srgbClr val="E6DFDA"/>
+            <a:srgbClr val="E2E0DE"/>
           </a:solidFill>
           <a:ln>
             <a:noFill/>
@@ -9993,7 +10092,7 @@
           </a:fontRef>
         </p:style>
         <p:txBody>
-          <a:bodyPr rtlCol="0" anchor="ctr" lIns="0" rIns="0"/>
+          <a:bodyPr rtlCol="0" anchor="ctr" lIns="0" rIns="0" tIns="0" bIns="0"/>
           <a:lstStyle/>
           <a:p>
             <a:pPr algn="ctr"/>
@@ -10060,7 +10159,7 @@
             </a:avLst>
           </a:prstGeom>
           <a:solidFill>
-            <a:srgbClr val="F7F4F2"/>
+            <a:srgbClr val="F5F4F4"/>
           </a:solidFill>
           <a:ln>
             <a:noFill/>
@@ -10104,7 +10203,7 @@
             <a:avLst/>
           </a:prstGeom>
           <a:solidFill>
-            <a:srgbClr val="E6DFDA"/>
+            <a:srgbClr val="E2E0DE"/>
           </a:solidFill>
           <a:ln>
             <a:noFill/>
@@ -10126,7 +10225,7 @@
           </a:fontRef>
         </p:style>
         <p:txBody>
-          <a:bodyPr rtlCol="0" anchor="ctr" lIns="0" rIns="0"/>
+          <a:bodyPr rtlCol="0" anchor="ctr" lIns="0" rIns="0" tIns="0" bIns="0"/>
           <a:lstStyle/>
           <a:p>
             <a:pPr algn="ctr"/>
@@ -10193,7 +10292,7 @@
             </a:avLst>
           </a:prstGeom>
           <a:solidFill>
-            <a:srgbClr val="F7F4F2"/>
+            <a:srgbClr val="F5F4F4"/>
           </a:solidFill>
           <a:ln>
             <a:noFill/>
@@ -10237,7 +10336,7 @@
             <a:avLst/>
           </a:prstGeom>
           <a:solidFill>
-            <a:srgbClr val="E6DFDA"/>
+            <a:srgbClr val="E2E0DE"/>
           </a:solidFill>
           <a:ln>
             <a:noFill/>
@@ -10259,7 +10358,7 @@
           </a:fontRef>
         </p:style>
         <p:txBody>
-          <a:bodyPr rtlCol="0" anchor="ctr" lIns="0" rIns="0"/>
+          <a:bodyPr rtlCol="0" anchor="ctr" lIns="0" rIns="0" tIns="0" bIns="0"/>
           <a:lstStyle/>
           <a:p>
             <a:pPr algn="ctr"/>
@@ -10415,7 +10514,7 @@
           </a:fontRef>
         </p:style>
         <p:txBody>
-          <a:bodyPr rtlCol="0" anchor="ctr" lIns="0" rIns="0"/>
+          <a:bodyPr rtlCol="0" anchor="ctr" lIns="0" rIns="0" tIns="0" bIns="0"/>
           <a:lstStyle/>
           <a:p>
             <a:pPr algn="ctr"/>
@@ -10460,7 +10559,7 @@
                 </a:solidFill>
                 <a:latin typeface="Calibri"/>
               </a:rPr>
-              <a:t>SELF-ASSESSMENT  ·  QUESTION 3 OF 5</a:t>
+              <a:t>SECTION 8  ·  QUESTION 3 OF 5</a:t>
             </a:r>
           </a:p>
         </p:txBody>
@@ -10643,7 +10742,7 @@
             </a:avLst>
           </a:prstGeom>
           <a:solidFill>
-            <a:srgbClr val="FBF3EE"/>
+            <a:srgbClr val="FAF4F2"/>
           </a:solidFill>
           <a:ln>
             <a:noFill/>
@@ -10709,7 +10808,7 @@
           </a:fontRef>
         </p:style>
         <p:txBody>
-          <a:bodyPr rtlCol="0" anchor="ctr" lIns="0" rIns="0"/>
+          <a:bodyPr rtlCol="0" anchor="ctr" lIns="0" rIns="0" tIns="0" bIns="0"/>
           <a:lstStyle/>
           <a:p>
             <a:pPr algn="ctr"/>
@@ -10776,7 +10875,7 @@
             </a:avLst>
           </a:prstGeom>
           <a:solidFill>
-            <a:srgbClr val="FBF3EE"/>
+            <a:srgbClr val="FAF4F2"/>
           </a:solidFill>
           <a:ln>
             <a:noFill/>
@@ -10842,7 +10941,7 @@
           </a:fontRef>
         </p:style>
         <p:txBody>
-          <a:bodyPr rtlCol="0" anchor="ctr" lIns="0" rIns="0"/>
+          <a:bodyPr rtlCol="0" anchor="ctr" lIns="0" rIns="0" tIns="0" bIns="0"/>
           <a:lstStyle/>
           <a:p>
             <a:pPr algn="ctr"/>
@@ -10909,7 +11008,7 @@
             </a:avLst>
           </a:prstGeom>
           <a:solidFill>
-            <a:srgbClr val="FBF3EE"/>
+            <a:srgbClr val="FAF4F2"/>
           </a:solidFill>
           <a:ln>
             <a:noFill/>
@@ -10975,7 +11074,7 @@
           </a:fontRef>
         </p:style>
         <p:txBody>
-          <a:bodyPr rtlCol="0" anchor="ctr" lIns="0" rIns="0"/>
+          <a:bodyPr rtlCol="0" anchor="ctr" lIns="0" rIns="0" tIns="0" bIns="0"/>
           <a:lstStyle/>
           <a:p>
             <a:pPr algn="ctr"/>
@@ -11042,7 +11141,7 @@
             </a:avLst>
           </a:prstGeom>
           <a:solidFill>
-            <a:srgbClr val="FBF3EE"/>
+            <a:srgbClr val="FAF4F2"/>
           </a:solidFill>
           <a:ln>
             <a:noFill/>
@@ -11108,7 +11207,7 @@
           </a:fontRef>
         </p:style>
         <p:txBody>
-          <a:bodyPr rtlCol="0" anchor="ctr" lIns="0" rIns="0"/>
+          <a:bodyPr rtlCol="0" anchor="ctr" lIns="0" rIns="0" tIns="0" bIns="0"/>
           <a:lstStyle/>
           <a:p>
             <a:pPr algn="ctr"/>
@@ -11221,7 +11320,7 @@
           </a:fontRef>
         </p:style>
         <p:txBody>
-          <a:bodyPr rtlCol="0" anchor="ctr" lIns="0" rIns="0"/>
+          <a:bodyPr rtlCol="0" anchor="ctr" lIns="0" rIns="0" tIns="0" bIns="0"/>
           <a:lstStyle/>
           <a:p>
             <a:pPr algn="ctr"/>
@@ -11266,7 +11365,7 @@
                 </a:solidFill>
                 <a:latin typeface="Calibri"/>
               </a:rPr>
-              <a:t>SECTION GOALS</a:t>
+              <a:t>SECTION 8</a:t>
             </a:r>
           </a:p>
         </p:txBody>
@@ -11406,14 +11505,14 @@
         </p:nvSpPr>
         <p:spPr>
           <a:xfrm>
-            <a:off x="548640" y="1618488"/>
+            <a:off x="548640" y="1572768"/>
             <a:ext cx="402336" cy="402336"/>
           </a:xfrm>
           <a:prstGeom prst="ellipse">
             <a:avLst/>
           </a:prstGeom>
           <a:solidFill>
-            <a:srgbClr val="E0EEF0"/>
+            <a:srgbClr val="E6EEEF"/>
           </a:solidFill>
           <a:ln>
             <a:noFill/>
@@ -11435,7 +11534,7 @@
           </a:fontRef>
         </p:style>
         <p:txBody>
-          <a:bodyPr rtlCol="0" anchor="ctr" lIns="0" rIns="0"/>
+          <a:bodyPr rtlCol="0" anchor="ctr" lIns="0" rIns="0" tIns="0" bIns="0"/>
           <a:lstStyle/>
           <a:p>
             <a:pPr algn="ctr"/>
@@ -11459,7 +11558,7 @@
         </p:nvSpPr>
         <p:spPr>
           <a:xfrm>
-            <a:off x="1143000" y="1636776"/>
+            <a:off x="1143000" y="1591056"/>
             <a:ext cx="6629400" cy="1142237"/>
           </a:xfrm>
           <a:prstGeom prst="rect">
@@ -11493,14 +11592,14 @@
         </p:nvSpPr>
         <p:spPr>
           <a:xfrm>
-            <a:off x="548640" y="2806445"/>
+            <a:off x="548640" y="2760726"/>
             <a:ext cx="402336" cy="402336"/>
           </a:xfrm>
           <a:prstGeom prst="ellipse">
             <a:avLst/>
           </a:prstGeom>
           <a:solidFill>
-            <a:srgbClr val="E0EEF0"/>
+            <a:srgbClr val="E6EEEF"/>
           </a:solidFill>
           <a:ln>
             <a:noFill/>
@@ -11522,7 +11621,7 @@
           </a:fontRef>
         </p:style>
         <p:txBody>
-          <a:bodyPr rtlCol="0" anchor="ctr" lIns="0" rIns="0"/>
+          <a:bodyPr rtlCol="0" anchor="ctr" lIns="0" rIns="0" tIns="0" bIns="0"/>
           <a:lstStyle/>
           <a:p>
             <a:pPr algn="ctr"/>
@@ -11546,7 +11645,7 @@
         </p:nvSpPr>
         <p:spPr>
           <a:xfrm>
-            <a:off x="1143000" y="2824733"/>
+            <a:off x="1143000" y="2779014"/>
             <a:ext cx="6629400" cy="808863"/>
           </a:xfrm>
           <a:prstGeom prst="rect">
@@ -11580,14 +11679,14 @@
         </p:nvSpPr>
         <p:spPr>
           <a:xfrm>
-            <a:off x="548640" y="3661028"/>
+            <a:off x="548640" y="3615309"/>
             <a:ext cx="402336" cy="402336"/>
           </a:xfrm>
           <a:prstGeom prst="ellipse">
             <a:avLst/>
           </a:prstGeom>
           <a:solidFill>
-            <a:srgbClr val="E0EEF0"/>
+            <a:srgbClr val="E6EEEF"/>
           </a:solidFill>
           <a:ln>
             <a:noFill/>
@@ -11609,7 +11708,7 @@
           </a:fontRef>
         </p:style>
         <p:txBody>
-          <a:bodyPr rtlCol="0" anchor="ctr" lIns="0" rIns="0"/>
+          <a:bodyPr rtlCol="0" anchor="ctr" lIns="0" rIns="0" tIns="0" bIns="0"/>
           <a:lstStyle/>
           <a:p>
             <a:pPr algn="ctr"/>
@@ -11633,7 +11732,7 @@
         </p:nvSpPr>
         <p:spPr>
           <a:xfrm>
-            <a:off x="1143000" y="3679316"/>
+            <a:off x="1143000" y="3633597"/>
             <a:ext cx="6629400" cy="1142237"/>
           </a:xfrm>
           <a:prstGeom prst="rect">
@@ -11667,14 +11766,14 @@
         </p:nvSpPr>
         <p:spPr>
           <a:xfrm>
-            <a:off x="548640" y="4848986"/>
+            <a:off x="548640" y="4803266"/>
             <a:ext cx="402336" cy="402336"/>
           </a:xfrm>
           <a:prstGeom prst="ellipse">
             <a:avLst/>
           </a:prstGeom>
           <a:solidFill>
-            <a:srgbClr val="E0EEF0"/>
+            <a:srgbClr val="E6EEEF"/>
           </a:solidFill>
           <a:ln>
             <a:noFill/>
@@ -11696,7 +11795,7 @@
           </a:fontRef>
         </p:style>
         <p:txBody>
-          <a:bodyPr rtlCol="0" anchor="ctr" lIns="0" rIns="0"/>
+          <a:bodyPr rtlCol="0" anchor="ctr" lIns="0" rIns="0" tIns="0" bIns="0"/>
           <a:lstStyle/>
           <a:p>
             <a:pPr algn="ctr"/>
@@ -11720,7 +11819,7 @@
         </p:nvSpPr>
         <p:spPr>
           <a:xfrm>
-            <a:off x="1143000" y="4867274"/>
+            <a:off x="1143000" y="4821555"/>
             <a:ext cx="6629400" cy="1142237"/>
           </a:xfrm>
           <a:prstGeom prst="rect">
@@ -11763,7 +11862,7 @@
             </a:avLst>
           </a:prstGeom>
           <a:solidFill>
-            <a:srgbClr val="FBF3EE"/>
+            <a:srgbClr val="FAF4F2"/>
           </a:solidFill>
           <a:ln>
             <a:noFill/>
@@ -11959,7 +12058,7 @@
           </a:fontRef>
         </p:style>
         <p:txBody>
-          <a:bodyPr rtlCol="0" anchor="ctr" lIns="0" rIns="0"/>
+          <a:bodyPr rtlCol="0" anchor="ctr" lIns="0" rIns="0" tIns="0" bIns="0"/>
           <a:lstStyle/>
           <a:p>
             <a:pPr algn="ctr"/>
@@ -12004,7 +12103,7 @@
                 </a:solidFill>
                 <a:latin typeface="Calibri"/>
               </a:rPr>
-              <a:t>SELF-ASSESSMENT  ·  QUESTION 3 OF 5  ·  ANSWER</a:t>
+              <a:t>SECTION 8  ·  QUESTION 3 OF 5  ·  ANSWER</a:t>
             </a:r>
           </a:p>
         </p:txBody>
@@ -12187,7 +12286,7 @@
             </a:avLst>
           </a:prstGeom>
           <a:solidFill>
-            <a:srgbClr val="F7F4F2"/>
+            <a:srgbClr val="F5F4F4"/>
           </a:solidFill>
           <a:ln>
             <a:noFill/>
@@ -12231,7 +12330,7 @@
             <a:avLst/>
           </a:prstGeom>
           <a:solidFill>
-            <a:srgbClr val="E6DFDA"/>
+            <a:srgbClr val="E2E0DE"/>
           </a:solidFill>
           <a:ln>
             <a:noFill/>
@@ -12253,7 +12352,7 @@
           </a:fontRef>
         </p:style>
         <p:txBody>
-          <a:bodyPr rtlCol="0" anchor="ctr" lIns="0" rIns="0"/>
+          <a:bodyPr rtlCol="0" anchor="ctr" lIns="0" rIns="0" tIns="0" bIns="0"/>
           <a:lstStyle/>
           <a:p>
             <a:pPr algn="ctr"/>
@@ -12320,7 +12419,7 @@
             </a:avLst>
           </a:prstGeom>
           <a:solidFill>
-            <a:srgbClr val="F7F4F2"/>
+            <a:srgbClr val="F5F4F4"/>
           </a:solidFill>
           <a:ln>
             <a:noFill/>
@@ -12364,7 +12463,7 @@
             <a:avLst/>
           </a:prstGeom>
           <a:solidFill>
-            <a:srgbClr val="E6DFDA"/>
+            <a:srgbClr val="E2E0DE"/>
           </a:solidFill>
           <a:ln>
             <a:noFill/>
@@ -12386,7 +12485,7 @@
           </a:fontRef>
         </p:style>
         <p:txBody>
-          <a:bodyPr rtlCol="0" anchor="ctr" lIns="0" rIns="0"/>
+          <a:bodyPr rtlCol="0" anchor="ctr" lIns="0" rIns="0" tIns="0" bIns="0"/>
           <a:lstStyle/>
           <a:p>
             <a:pPr algn="ctr"/>
@@ -12519,7 +12618,7 @@
           </a:fontRef>
         </p:style>
         <p:txBody>
-          <a:bodyPr rtlCol="0" anchor="ctr" lIns="0" rIns="0"/>
+          <a:bodyPr rtlCol="0" anchor="ctr" lIns="0" rIns="0" tIns="0" bIns="0"/>
           <a:lstStyle/>
           <a:p>
             <a:pPr algn="ctr"/>
@@ -12586,7 +12685,7 @@
             </a:avLst>
           </a:prstGeom>
           <a:solidFill>
-            <a:srgbClr val="F7F4F2"/>
+            <a:srgbClr val="F5F4F4"/>
           </a:solidFill>
           <a:ln>
             <a:noFill/>
@@ -12630,7 +12729,7 @@
             <a:avLst/>
           </a:prstGeom>
           <a:solidFill>
-            <a:srgbClr val="E6DFDA"/>
+            <a:srgbClr val="E2E0DE"/>
           </a:solidFill>
           <a:ln>
             <a:noFill/>
@@ -12652,7 +12751,7 @@
           </a:fontRef>
         </p:style>
         <p:txBody>
-          <a:bodyPr rtlCol="0" anchor="ctr" lIns="0" rIns="0"/>
+          <a:bodyPr rtlCol="0" anchor="ctr" lIns="0" rIns="0" tIns="0" bIns="0"/>
           <a:lstStyle/>
           <a:p>
             <a:pPr algn="ctr"/>
@@ -12808,7 +12907,7 @@
           </a:fontRef>
         </p:style>
         <p:txBody>
-          <a:bodyPr rtlCol="0" anchor="ctr" lIns="0" rIns="0"/>
+          <a:bodyPr rtlCol="0" anchor="ctr" lIns="0" rIns="0" tIns="0" bIns="0"/>
           <a:lstStyle/>
           <a:p>
             <a:pPr algn="ctr"/>
@@ -12853,7 +12952,7 @@
                 </a:solidFill>
                 <a:latin typeface="Calibri"/>
               </a:rPr>
-              <a:t>SELF-ASSESSMENT  ·  QUESTION 4 OF 5</a:t>
+              <a:t>SECTION 8  ·  QUESTION 4 OF 5</a:t>
             </a:r>
           </a:p>
         </p:txBody>
@@ -13036,7 +13135,7 @@
             </a:avLst>
           </a:prstGeom>
           <a:solidFill>
-            <a:srgbClr val="FBF3EE"/>
+            <a:srgbClr val="FAF4F2"/>
           </a:solidFill>
           <a:ln>
             <a:noFill/>
@@ -13102,7 +13201,7 @@
           </a:fontRef>
         </p:style>
         <p:txBody>
-          <a:bodyPr rtlCol="0" anchor="ctr" lIns="0" rIns="0"/>
+          <a:bodyPr rtlCol="0" anchor="ctr" lIns="0" rIns="0" tIns="0" bIns="0"/>
           <a:lstStyle/>
           <a:p>
             <a:pPr algn="ctr"/>
@@ -13169,7 +13268,7 @@
             </a:avLst>
           </a:prstGeom>
           <a:solidFill>
-            <a:srgbClr val="FBF3EE"/>
+            <a:srgbClr val="FAF4F2"/>
           </a:solidFill>
           <a:ln>
             <a:noFill/>
@@ -13235,7 +13334,7 @@
           </a:fontRef>
         </p:style>
         <p:txBody>
-          <a:bodyPr rtlCol="0" anchor="ctr" lIns="0" rIns="0"/>
+          <a:bodyPr rtlCol="0" anchor="ctr" lIns="0" rIns="0" tIns="0" bIns="0"/>
           <a:lstStyle/>
           <a:p>
             <a:pPr algn="ctr"/>
@@ -13302,7 +13401,7 @@
             </a:avLst>
           </a:prstGeom>
           <a:solidFill>
-            <a:srgbClr val="FBF3EE"/>
+            <a:srgbClr val="FAF4F2"/>
           </a:solidFill>
           <a:ln>
             <a:noFill/>
@@ -13368,7 +13467,7 @@
           </a:fontRef>
         </p:style>
         <p:txBody>
-          <a:bodyPr rtlCol="0" anchor="ctr" lIns="0" rIns="0"/>
+          <a:bodyPr rtlCol="0" anchor="ctr" lIns="0" rIns="0" tIns="0" bIns="0"/>
           <a:lstStyle/>
           <a:p>
             <a:pPr algn="ctr"/>
@@ -13435,7 +13534,7 @@
             </a:avLst>
           </a:prstGeom>
           <a:solidFill>
-            <a:srgbClr val="FBF3EE"/>
+            <a:srgbClr val="FAF4F2"/>
           </a:solidFill>
           <a:ln>
             <a:noFill/>
@@ -13501,7 +13600,7 @@
           </a:fontRef>
         </p:style>
         <p:txBody>
-          <a:bodyPr rtlCol="0" anchor="ctr" lIns="0" rIns="0"/>
+          <a:bodyPr rtlCol="0" anchor="ctr" lIns="0" rIns="0" tIns="0" bIns="0"/>
           <a:lstStyle/>
           <a:p>
             <a:pPr algn="ctr"/>
@@ -13614,7 +13713,7 @@
           </a:fontRef>
         </p:style>
         <p:txBody>
-          <a:bodyPr rtlCol="0" anchor="ctr" lIns="0" rIns="0"/>
+          <a:bodyPr rtlCol="0" anchor="ctr" lIns="0" rIns="0" tIns="0" bIns="0"/>
           <a:lstStyle/>
           <a:p>
             <a:pPr algn="ctr"/>
@@ -13659,7 +13758,7 @@
                 </a:solidFill>
                 <a:latin typeface="Calibri"/>
               </a:rPr>
-              <a:t>SELF-ASSESSMENT  ·  QUESTION 4 OF 5  ·  ANSWER</a:t>
+              <a:t>SECTION 8  ·  QUESTION 4 OF 5  ·  ANSWER</a:t>
             </a:r>
           </a:p>
         </p:txBody>
@@ -13842,7 +13941,7 @@
             </a:avLst>
           </a:prstGeom>
           <a:solidFill>
-            <a:srgbClr val="F7F4F2"/>
+            <a:srgbClr val="F5F4F4"/>
           </a:solidFill>
           <a:ln>
             <a:noFill/>
@@ -13886,7 +13985,7 @@
             <a:avLst/>
           </a:prstGeom>
           <a:solidFill>
-            <a:srgbClr val="E6DFDA"/>
+            <a:srgbClr val="E2E0DE"/>
           </a:solidFill>
           <a:ln>
             <a:noFill/>
@@ -13908,7 +14007,7 @@
           </a:fontRef>
         </p:style>
         <p:txBody>
-          <a:bodyPr rtlCol="0" anchor="ctr" lIns="0" rIns="0"/>
+          <a:bodyPr rtlCol="0" anchor="ctr" lIns="0" rIns="0" tIns="0" bIns="0"/>
           <a:lstStyle/>
           <a:p>
             <a:pPr algn="ctr"/>
@@ -14041,7 +14140,7 @@
           </a:fontRef>
         </p:style>
         <p:txBody>
-          <a:bodyPr rtlCol="0" anchor="ctr" lIns="0" rIns="0"/>
+          <a:bodyPr rtlCol="0" anchor="ctr" lIns="0" rIns="0" tIns="0" bIns="0"/>
           <a:lstStyle/>
           <a:p>
             <a:pPr algn="ctr"/>
@@ -14108,7 +14207,7 @@
             </a:avLst>
           </a:prstGeom>
           <a:solidFill>
-            <a:srgbClr val="F7F4F2"/>
+            <a:srgbClr val="F5F4F4"/>
           </a:solidFill>
           <a:ln>
             <a:noFill/>
@@ -14152,7 +14251,7 @@
             <a:avLst/>
           </a:prstGeom>
           <a:solidFill>
-            <a:srgbClr val="E6DFDA"/>
+            <a:srgbClr val="E2E0DE"/>
           </a:solidFill>
           <a:ln>
             <a:noFill/>
@@ -14174,7 +14273,7 @@
           </a:fontRef>
         </p:style>
         <p:txBody>
-          <a:bodyPr rtlCol="0" anchor="ctr" lIns="0" rIns="0"/>
+          <a:bodyPr rtlCol="0" anchor="ctr" lIns="0" rIns="0" tIns="0" bIns="0"/>
           <a:lstStyle/>
           <a:p>
             <a:pPr algn="ctr"/>
@@ -14241,7 +14340,7 @@
             </a:avLst>
           </a:prstGeom>
           <a:solidFill>
-            <a:srgbClr val="F7F4F2"/>
+            <a:srgbClr val="F5F4F4"/>
           </a:solidFill>
           <a:ln>
             <a:noFill/>
@@ -14285,7 +14384,7 @@
             <a:avLst/>
           </a:prstGeom>
           <a:solidFill>
-            <a:srgbClr val="E6DFDA"/>
+            <a:srgbClr val="E2E0DE"/>
           </a:solidFill>
           <a:ln>
             <a:noFill/>
@@ -14307,7 +14406,7 @@
           </a:fontRef>
         </p:style>
         <p:txBody>
-          <a:bodyPr rtlCol="0" anchor="ctr" lIns="0" rIns="0"/>
+          <a:bodyPr rtlCol="0" anchor="ctr" lIns="0" rIns="0" tIns="0" bIns="0"/>
           <a:lstStyle/>
           <a:p>
             <a:pPr algn="ctr"/>
@@ -14463,7 +14562,7 @@
           </a:fontRef>
         </p:style>
         <p:txBody>
-          <a:bodyPr rtlCol="0" anchor="ctr" lIns="0" rIns="0"/>
+          <a:bodyPr rtlCol="0" anchor="ctr" lIns="0" rIns="0" tIns="0" bIns="0"/>
           <a:lstStyle/>
           <a:p>
             <a:pPr algn="ctr"/>
@@ -14508,7 +14607,7 @@
                 </a:solidFill>
                 <a:latin typeface="Calibri"/>
               </a:rPr>
-              <a:t>SELF-ASSESSMENT  ·  QUESTION 5 OF 5</a:t>
+              <a:t>SECTION 8  ·  QUESTION 5 OF 5</a:t>
             </a:r>
           </a:p>
         </p:txBody>
@@ -14691,7 +14790,7 @@
             </a:avLst>
           </a:prstGeom>
           <a:solidFill>
-            <a:srgbClr val="FBF3EE"/>
+            <a:srgbClr val="FAF4F2"/>
           </a:solidFill>
           <a:ln>
             <a:noFill/>
@@ -14757,7 +14856,7 @@
           </a:fontRef>
         </p:style>
         <p:txBody>
-          <a:bodyPr rtlCol="0" anchor="ctr" lIns="0" rIns="0"/>
+          <a:bodyPr rtlCol="0" anchor="ctr" lIns="0" rIns="0" tIns="0" bIns="0"/>
           <a:lstStyle/>
           <a:p>
             <a:pPr algn="ctr"/>
@@ -14824,7 +14923,7 @@
             </a:avLst>
           </a:prstGeom>
           <a:solidFill>
-            <a:srgbClr val="FBF3EE"/>
+            <a:srgbClr val="FAF4F2"/>
           </a:solidFill>
           <a:ln>
             <a:noFill/>
@@ -14890,7 +14989,7 @@
           </a:fontRef>
         </p:style>
         <p:txBody>
-          <a:bodyPr rtlCol="0" anchor="ctr" lIns="0" rIns="0"/>
+          <a:bodyPr rtlCol="0" anchor="ctr" lIns="0" rIns="0" tIns="0" bIns="0"/>
           <a:lstStyle/>
           <a:p>
             <a:pPr algn="ctr"/>
@@ -14957,7 +15056,7 @@
             </a:avLst>
           </a:prstGeom>
           <a:solidFill>
-            <a:srgbClr val="FBF3EE"/>
+            <a:srgbClr val="FAF4F2"/>
           </a:solidFill>
           <a:ln>
             <a:noFill/>
@@ -15023,7 +15122,7 @@
           </a:fontRef>
         </p:style>
         <p:txBody>
-          <a:bodyPr rtlCol="0" anchor="ctr" lIns="0" rIns="0"/>
+          <a:bodyPr rtlCol="0" anchor="ctr" lIns="0" rIns="0" tIns="0" bIns="0"/>
           <a:lstStyle/>
           <a:p>
             <a:pPr algn="ctr"/>
@@ -15090,7 +15189,7 @@
             </a:avLst>
           </a:prstGeom>
           <a:solidFill>
-            <a:srgbClr val="FBF3EE"/>
+            <a:srgbClr val="FAF4F2"/>
           </a:solidFill>
           <a:ln>
             <a:noFill/>
@@ -15156,7 +15255,7 @@
           </a:fontRef>
         </p:style>
         <p:txBody>
-          <a:bodyPr rtlCol="0" anchor="ctr" lIns="0" rIns="0"/>
+          <a:bodyPr rtlCol="0" anchor="ctr" lIns="0" rIns="0" tIns="0" bIns="0"/>
           <a:lstStyle/>
           <a:p>
             <a:pPr algn="ctr"/>
@@ -15269,7 +15368,7 @@
           </a:fontRef>
         </p:style>
         <p:txBody>
-          <a:bodyPr rtlCol="0" anchor="ctr" lIns="0" rIns="0"/>
+          <a:bodyPr rtlCol="0" anchor="ctr" lIns="0" rIns="0" tIns="0" bIns="0"/>
           <a:lstStyle/>
           <a:p>
             <a:pPr algn="ctr"/>
@@ -15314,7 +15413,7 @@
                 </a:solidFill>
                 <a:latin typeface="Calibri"/>
               </a:rPr>
-              <a:t>SELF-ASSESSMENT  ·  QUESTION 5 OF 5  ·  ANSWER</a:t>
+              <a:t>SECTION 8  ·  QUESTION 5 OF 5  ·  ANSWER</a:t>
             </a:r>
           </a:p>
         </p:txBody>
@@ -15497,7 +15596,7 @@
             </a:avLst>
           </a:prstGeom>
           <a:solidFill>
-            <a:srgbClr val="F7F4F2"/>
+            <a:srgbClr val="F5F4F4"/>
           </a:solidFill>
           <a:ln>
             <a:noFill/>
@@ -15541,7 +15640,7 @@
             <a:avLst/>
           </a:prstGeom>
           <a:solidFill>
-            <a:srgbClr val="E6DFDA"/>
+            <a:srgbClr val="E2E0DE"/>
           </a:solidFill>
           <a:ln>
             <a:noFill/>
@@ -15563,7 +15662,7 @@
           </a:fontRef>
         </p:style>
         <p:txBody>
-          <a:bodyPr rtlCol="0" anchor="ctr" lIns="0" rIns="0"/>
+          <a:bodyPr rtlCol="0" anchor="ctr" lIns="0" rIns="0" tIns="0" bIns="0"/>
           <a:lstStyle/>
           <a:p>
             <a:pPr algn="ctr"/>
@@ -15630,7 +15729,7 @@
             </a:avLst>
           </a:prstGeom>
           <a:solidFill>
-            <a:srgbClr val="F7F4F2"/>
+            <a:srgbClr val="F5F4F4"/>
           </a:solidFill>
           <a:ln>
             <a:noFill/>
@@ -15674,7 +15773,7 @@
             <a:avLst/>
           </a:prstGeom>
           <a:solidFill>
-            <a:srgbClr val="E6DFDA"/>
+            <a:srgbClr val="E2E0DE"/>
           </a:solidFill>
           <a:ln>
             <a:noFill/>
@@ -15696,7 +15795,7 @@
           </a:fontRef>
         </p:style>
         <p:txBody>
-          <a:bodyPr rtlCol="0" anchor="ctr" lIns="0" rIns="0"/>
+          <a:bodyPr rtlCol="0" anchor="ctr" lIns="0" rIns="0" tIns="0" bIns="0"/>
           <a:lstStyle/>
           <a:p>
             <a:pPr algn="ctr"/>
@@ -15763,7 +15862,7 @@
             </a:avLst>
           </a:prstGeom>
           <a:solidFill>
-            <a:srgbClr val="F7F4F2"/>
+            <a:srgbClr val="F5F4F4"/>
           </a:solidFill>
           <a:ln>
             <a:noFill/>
@@ -15807,7 +15906,7 @@
             <a:avLst/>
           </a:prstGeom>
           <a:solidFill>
-            <a:srgbClr val="E6DFDA"/>
+            <a:srgbClr val="E2E0DE"/>
           </a:solidFill>
           <a:ln>
             <a:noFill/>
@@ -15829,7 +15928,7 @@
           </a:fontRef>
         </p:style>
         <p:txBody>
-          <a:bodyPr rtlCol="0" anchor="ctr" lIns="0" rIns="0"/>
+          <a:bodyPr rtlCol="0" anchor="ctr" lIns="0" rIns="0" tIns="0" bIns="0"/>
           <a:lstStyle/>
           <a:p>
             <a:pPr algn="ctr"/>
@@ -15962,7 +16061,7 @@
           </a:fontRef>
         </p:style>
         <p:txBody>
-          <a:bodyPr rtlCol="0" anchor="ctr" lIns="0" rIns="0"/>
+          <a:bodyPr rtlCol="0" anchor="ctr" lIns="0" rIns="0" tIns="0" bIns="0"/>
           <a:lstStyle/>
           <a:p>
             <a:pPr algn="ctr"/>
@@ -16147,11 +16246,10 @@
           </a:bodyPr>
           <a:lstStyle/>
           <a:p>
-            <a:pPr algn="l"/>
             <a:r>
               <a:rPr sz="13000" i="0" b="1">
                 <a:solidFill>
-                  <a:srgbClr val="F6E5DE"/>
+                  <a:srgbClr val="F1E3DF"/>
                 </a:solidFill>
                 <a:latin typeface="Cambria"/>
               </a:rPr>
@@ -16196,7 +16294,7 @@
             <a:r>
               <a:rPr sz="1400" i="0" b="1" spc="150">
                 <a:solidFill>
-                  <a:srgbClr val="F6E5DE"/>
+                  <a:srgbClr val="F1E3DF"/>
                 </a:solidFill>
                 <a:latin typeface="Calibri"/>
               </a:rPr>
@@ -16248,7 +16346,7 @@
         <p:spPr>
           <a:xfrm>
             <a:off x="4526280" y="6419088"/>
-            <a:ext cx="5486400" cy="274320"/>
+            <a:ext cx="8229600" cy="274320"/>
           </a:xfrm>
           <a:prstGeom prst="rect">
             <a:avLst/>
@@ -16383,7 +16481,7 @@
             <a:r>
               <a:rPr sz="1300" i="0" b="1" spc="200">
                 <a:solidFill>
-                  <a:srgbClr val="F3E6D8"/>
+                  <a:srgbClr val="F2E5E1"/>
                 </a:solidFill>
                 <a:latin typeface="Calibri"/>
               </a:rPr>
@@ -16441,7 +16539,7 @@
             <a:avLst/>
           </a:prstGeom>
           <a:solidFill>
-            <a:srgbClr val="F3E6D8"/>
+            <a:srgbClr val="F2E5E1"/>
           </a:solidFill>
           <a:ln>
             <a:noFill/>
@@ -16463,7 +16561,7 @@
           </a:fontRef>
         </p:style>
         <p:txBody>
-          <a:bodyPr rtlCol="0" anchor="ctr" lIns="0" rIns="0"/>
+          <a:bodyPr rtlCol="0" anchor="ctr" lIns="0" rIns="0" tIns="0" bIns="0"/>
           <a:lstStyle/>
           <a:p>
             <a:pPr algn="ctr"/>
@@ -16528,7 +16626,7 @@
             <a:avLst/>
           </a:prstGeom>
           <a:solidFill>
-            <a:srgbClr val="F3E6D8"/>
+            <a:srgbClr val="F2E5E1"/>
           </a:solidFill>
           <a:ln>
             <a:noFill/>
@@ -16550,7 +16648,7 @@
           </a:fontRef>
         </p:style>
         <p:txBody>
-          <a:bodyPr rtlCol="0" anchor="ctr" lIns="0" rIns="0"/>
+          <a:bodyPr rtlCol="0" anchor="ctr" lIns="0" rIns="0" tIns="0" bIns="0"/>
           <a:lstStyle/>
           <a:p>
             <a:pPr algn="ctr"/>
@@ -16615,7 +16713,7 @@
             <a:avLst/>
           </a:prstGeom>
           <a:solidFill>
-            <a:srgbClr val="F3E6D8"/>
+            <a:srgbClr val="F2E5E1"/>
           </a:solidFill>
           <a:ln>
             <a:noFill/>
@@ -16637,7 +16735,7 @@
           </a:fontRef>
         </p:style>
         <p:txBody>
-          <a:bodyPr rtlCol="0" anchor="ctr" lIns="0" rIns="0"/>
+          <a:bodyPr rtlCol="0" anchor="ctr" lIns="0" rIns="0" tIns="0" bIns="0"/>
           <a:lstStyle/>
           <a:p>
             <a:pPr algn="ctr"/>
@@ -16702,7 +16800,7 @@
             <a:avLst/>
           </a:prstGeom>
           <a:solidFill>
-            <a:srgbClr val="F3E6D8"/>
+            <a:srgbClr val="F2E5E1"/>
           </a:solidFill>
           <a:ln>
             <a:noFill/>
@@ -16724,7 +16822,7 @@
           </a:fontRef>
         </p:style>
         <p:txBody>
-          <a:bodyPr rtlCol="0" anchor="ctr" lIns="0" rIns="0"/>
+          <a:bodyPr rtlCol="0" anchor="ctr" lIns="0" rIns="0" tIns="0" bIns="0"/>
           <a:lstStyle/>
           <a:p>
             <a:pPr algn="ctr"/>
@@ -16789,7 +16887,7 @@
             <a:avLst/>
           </a:prstGeom>
           <a:solidFill>
-            <a:srgbClr val="F3E6D8"/>
+            <a:srgbClr val="F2E5E1"/>
           </a:solidFill>
           <a:ln>
             <a:noFill/>
@@ -16811,7 +16909,7 @@
           </a:fontRef>
         </p:style>
         <p:txBody>
-          <a:bodyPr rtlCol="0" anchor="ctr" lIns="0" rIns="0"/>
+          <a:bodyPr rtlCol="0" anchor="ctr" lIns="0" rIns="0" tIns="0" bIns="0"/>
           <a:lstStyle/>
           <a:p>
             <a:pPr algn="ctr"/>
@@ -16972,7 +17070,7 @@
           </a:fontRef>
         </p:style>
         <p:txBody>
-          <a:bodyPr rtlCol="0" anchor="ctr" lIns="0" rIns="0"/>
+          <a:bodyPr rtlCol="0" anchor="ctr" lIns="0" rIns="0" tIns="0" bIns="0"/>
           <a:lstStyle/>
           <a:p>
             <a:pPr algn="ctr"/>
@@ -17151,20 +17249,100 @@
       </p:pic>
       <p:sp>
         <p:nvSpPr>
-          <p:cNvPr id="8" name="Oval 7"/>
+          <p:cNvPr id="8" name="TextBox 7"/>
+          <p:cNvSpPr txBox="1"/>
+          <p:nvPr/>
+        </p:nvSpPr>
+        <p:spPr>
+          <a:xfrm>
+            <a:off x="548640" y="1554480"/>
+            <a:ext cx="4480560" cy="4617720"/>
+          </a:xfrm>
+          <a:prstGeom prst="rect">
+            <a:avLst/>
+          </a:prstGeom>
+          <a:noFill/>
+        </p:spPr>
+        <p:txBody>
+          <a:bodyPr wrap="square" anchor="t" lIns="0" rIns="0" tIns="0" bIns="0">
+            <a:spAutoFit/>
+          </a:bodyPr>
+          <a:lstStyle/>
+          <a:p>
+            <a:pPr>
+              <a:spcAft>
+                <a:spcPts val="800"/>
+              </a:spcAft>
+            </a:pPr>
+            <a:r>
+              <a:rPr sz="1700" i="0" b="1">
+                <a:solidFill>
+                  <a:srgbClr val="2B211C"/>
+                </a:solidFill>
+                <a:latin typeface="Calibri"/>
+              </a:rPr>
+              <a:t>Causality</a:t>
+            </a:r>
+            <a:r>
+              <a:rPr sz="1700" i="0" b="0">
+                <a:solidFill>
+                  <a:srgbClr val="2B211C"/>
+                </a:solidFill>
+                <a:latin typeface="Calibri"/>
+              </a:rPr>
+              <a:t> is the likelihood that a medicine caused an event. Most ADRs cannot be proved, so we grade how likely the link is. Four questions do most of the work:</a:t>
+            </a:r>
+          </a:p>
+          <a:p>
+            <a:pPr>
+              <a:spcAft>
+                <a:spcPts val="800"/>
+              </a:spcAft>
+            </a:pPr>
+            <a:r>
+              <a:rPr sz="1700" i="0" b="0">
+                <a:solidFill>
+                  <a:srgbClr val="2B211C"/>
+                </a:solidFill>
+                <a:latin typeface="Calibri"/>
+              </a:rPr>
+              <a:t>Other clues are a known association (the ADR is already described), a dose-response relationship (worse with a higher dose), and objective evidence such as a drug level or a laboratory test.</a:t>
+            </a:r>
+          </a:p>
+          <a:p>
+            <a:pPr>
+              <a:spcAft>
+                <a:spcPts val="800"/>
+              </a:spcAft>
+            </a:pPr>
+            <a:r>
+              <a:rPr sz="1700" i="0" b="0">
+                <a:solidFill>
+                  <a:srgbClr val="2B211C"/>
+                </a:solidFill>
+                <a:latin typeface="Calibri"/>
+              </a:rPr>
+              <a:t>Rechallenge is strong evidence but is often unsafe. Never rechallenge on purpose after a serious reaction such as anaphylaxis.</a:t>
+            </a:r>
+          </a:p>
+        </p:txBody>
+      </p:sp>
+      <p:sp>
+        <p:nvSpPr>
+          <p:cNvPr id="9" name="Oval 8"/>
           <p:cNvSpPr/>
           <p:nvPr/>
         </p:nvSpPr>
         <p:spPr>
           <a:xfrm>
-            <a:off x="548640" y="1618488"/>
+            <a:off x="5394959" y="1572768"/>
             <a:ext cx="402336" cy="402336"/>
           </a:xfrm>
           <a:prstGeom prst="ellipse">
             <a:avLst/>
           </a:prstGeom>
           <a:solidFill>
-            <a:srgbClr val="E0EEF0"/>
+            <a:srgbClr val="E6EEEF"/>
           </a:solidFill>
           <a:ln>
             <a:noFill/>
@@ -17186,7 +17364,7 @@
           </a:fontRef>
         </p:style>
         <p:txBody>
-          <a:bodyPr rtlCol="0" anchor="ctr" lIns="0" rIns="0"/>
+          <a:bodyPr rtlCol="0" anchor="ctr" lIns="0" rIns="0" tIns="0" bIns="0"/>
           <a:lstStyle/>
           <a:p>
             <a:pPr algn="ctr"/>
@@ -17204,14 +17382,14 @@
       </p:sp>
       <p:sp>
         <p:nvSpPr>
-          <p:cNvPr id="9" name="TextBox 8"/>
+          <p:cNvPr id="10" name="TextBox 9"/>
           <p:cNvSpPr txBox="1"/>
           <p:nvPr/>
         </p:nvSpPr>
         <p:spPr>
           <a:xfrm>
-            <a:off x="1143000" y="1636776"/>
-            <a:ext cx="10500055" cy="808863"/>
+            <a:off x="5989320" y="1591056"/>
+            <a:ext cx="5653735" cy="1108710"/>
           </a:xfrm>
           <a:prstGeom prst="rect">
             <a:avLst/>
@@ -17247,20 +17425,20 @@
       </p:sp>
       <p:sp>
         <p:nvSpPr>
-          <p:cNvPr id="10" name="Oval 9"/>
+          <p:cNvPr id="11" name="Oval 10"/>
           <p:cNvSpPr/>
           <p:nvPr/>
         </p:nvSpPr>
         <p:spPr>
           <a:xfrm>
-            <a:off x="548640" y="2473071"/>
+            <a:off x="5394959" y="2727198"/>
             <a:ext cx="402336" cy="402336"/>
           </a:xfrm>
           <a:prstGeom prst="ellipse">
             <a:avLst/>
           </a:prstGeom>
           <a:solidFill>
-            <a:srgbClr val="E0EEF0"/>
+            <a:srgbClr val="E6EEEF"/>
           </a:solidFill>
           <a:ln>
             <a:noFill/>
@@ -17282,7 +17460,7 @@
           </a:fontRef>
         </p:style>
         <p:txBody>
-          <a:bodyPr rtlCol="0" anchor="ctr" lIns="0" rIns="0"/>
+          <a:bodyPr rtlCol="0" anchor="ctr" lIns="0" rIns="0" tIns="0" bIns="0"/>
           <a:lstStyle/>
           <a:p>
             <a:pPr algn="ctr"/>
@@ -17300,14 +17478,14 @@
       </p:sp>
       <p:sp>
         <p:nvSpPr>
-          <p:cNvPr id="11" name="TextBox 10"/>
+          <p:cNvPr id="12" name="TextBox 11"/>
           <p:cNvSpPr txBox="1"/>
           <p:nvPr/>
         </p:nvSpPr>
         <p:spPr>
           <a:xfrm>
-            <a:off x="1143000" y="2491359"/>
-            <a:ext cx="10500055" cy="808863"/>
+            <a:off x="5989320" y="2745486"/>
+            <a:ext cx="5653735" cy="1108710"/>
           </a:xfrm>
           <a:prstGeom prst="rect">
             <a:avLst/>
@@ -17343,20 +17521,20 @@
       </p:sp>
       <p:sp>
         <p:nvSpPr>
-          <p:cNvPr id="12" name="Oval 11"/>
+          <p:cNvPr id="13" name="Oval 12"/>
           <p:cNvSpPr/>
           <p:nvPr/>
         </p:nvSpPr>
         <p:spPr>
           <a:xfrm>
-            <a:off x="548640" y="3327654"/>
+            <a:off x="5394959" y="3881627"/>
             <a:ext cx="402336" cy="402336"/>
           </a:xfrm>
           <a:prstGeom prst="ellipse">
             <a:avLst/>
           </a:prstGeom>
           <a:solidFill>
-            <a:srgbClr val="E0EEF0"/>
+            <a:srgbClr val="E6EEEF"/>
           </a:solidFill>
           <a:ln>
             <a:noFill/>
@@ -17378,7 +17556,7 @@
           </a:fontRef>
         </p:style>
         <p:txBody>
-          <a:bodyPr rtlCol="0" anchor="ctr" lIns="0" rIns="0"/>
+          <a:bodyPr rtlCol="0" anchor="ctr" lIns="0" rIns="0" tIns="0" bIns="0"/>
           <a:lstStyle/>
           <a:p>
             <a:pPr algn="ctr"/>
@@ -17396,14 +17574,14 @@
       </p:sp>
       <p:sp>
         <p:nvSpPr>
-          <p:cNvPr id="13" name="TextBox 12"/>
+          <p:cNvPr id="14" name="TextBox 13"/>
           <p:cNvSpPr txBox="1"/>
           <p:nvPr/>
         </p:nvSpPr>
         <p:spPr>
           <a:xfrm>
-            <a:off x="1143000" y="3345942"/>
-            <a:ext cx="10500055" cy="1142237"/>
+            <a:off x="5989320" y="3899915"/>
+            <a:ext cx="5653735" cy="1108710"/>
           </a:xfrm>
           <a:prstGeom prst="rect">
             <a:avLst/>
@@ -17439,20 +17617,20 @@
       </p:sp>
       <p:sp>
         <p:nvSpPr>
-          <p:cNvPr id="14" name="Oval 13"/>
+          <p:cNvPr id="15" name="Oval 14"/>
           <p:cNvSpPr/>
           <p:nvPr/>
         </p:nvSpPr>
         <p:spPr>
           <a:xfrm>
-            <a:off x="548640" y="4515611"/>
+            <a:off x="5394959" y="5036057"/>
             <a:ext cx="402336" cy="402336"/>
           </a:xfrm>
           <a:prstGeom prst="ellipse">
             <a:avLst/>
           </a:prstGeom>
           <a:solidFill>
-            <a:srgbClr val="E0EEF0"/>
+            <a:srgbClr val="E6EEEF"/>
           </a:solidFill>
           <a:ln>
             <a:noFill/>
@@ -17474,7 +17652,7 @@
           </a:fontRef>
         </p:style>
         <p:txBody>
-          <a:bodyPr rtlCol="0" anchor="ctr" lIns="0" rIns="0"/>
+          <a:bodyPr rtlCol="0" anchor="ctr" lIns="0" rIns="0" tIns="0" bIns="0"/>
           <a:lstStyle/>
           <a:p>
             <a:pPr algn="ctr"/>
@@ -17492,14 +17670,14 @@
       </p:sp>
       <p:sp>
         <p:nvSpPr>
-          <p:cNvPr id="15" name="TextBox 14"/>
+          <p:cNvPr id="16" name="TextBox 15"/>
           <p:cNvSpPr txBox="1"/>
           <p:nvPr/>
         </p:nvSpPr>
         <p:spPr>
           <a:xfrm>
-            <a:off x="1143000" y="4533900"/>
-            <a:ext cx="10500055" cy="808863"/>
+            <a:off x="5989320" y="5054346"/>
+            <a:ext cx="5653735" cy="1108710"/>
           </a:xfrm>
           <a:prstGeom prst="rect">
             <a:avLst/>
@@ -17596,7 +17774,7 @@
           </a:fontRef>
         </p:style>
         <p:txBody>
-          <a:bodyPr rtlCol="0" anchor="ctr" lIns="0" rIns="0"/>
+          <a:bodyPr rtlCol="0" anchor="ctr" lIns="0" rIns="0" tIns="0" bIns="0"/>
           <a:lstStyle/>
           <a:p>
             <a:pPr algn="ctr"/>
@@ -17782,8 +17960,8 @@
           <p:nvPr/>
         </p:nvGraphicFramePr>
         <p:xfrm>
-          <a:off x="548640" y="1600200"/>
-          <a:ext cx="11094413" cy="3108960"/>
+          <a:off x="548640" y="1554480"/>
+          <a:ext cx="11094413" cy="2560320"/>
         </p:xfrm>
         <a:graphic>
           <a:graphicData uri="http://schemas.openxmlformats.org/drawingml/2006/table">
@@ -17797,7 +17975,7 @@
                 <a:gridCol w="2195151"/>
                 <a:gridCol w="2195151"/>
               </a:tblGrid>
-              <a:tr h="777240">
+              <a:tr h="640080">
                 <a:tc>
                   <a:txBody>
                     <a:bodyPr/>
@@ -17887,7 +18065,7 @@
                   </a:tcPr>
                 </a:tc>
               </a:tr>
-              <a:tr h="777240">
+              <a:tr h="640080">
                 <a:tc>
                   <a:txBody>
                     <a:bodyPr/>
@@ -17977,7 +18155,7 @@
                   </a:tcPr>
                 </a:tc>
               </a:tr>
-              <a:tr h="777240">
+              <a:tr h="640080">
                 <a:tc>
                   <a:txBody>
                     <a:bodyPr/>
@@ -17996,7 +18174,7 @@
                   </a:txBody>
                   <a:tcPr marL="109728" marR="109728" marT="45720" marB="45720" anchor="ctr">
                     <a:solidFill>
-                      <a:srgbClr val="FBF3EE"/>
+                      <a:srgbClr val="FAF4F2"/>
                     </a:solidFill>
                   </a:tcPr>
                 </a:tc>
@@ -18018,7 +18196,7 @@
                   </a:txBody>
                   <a:tcPr marL="109728" marR="109728" marT="45720" marB="45720" anchor="ctr">
                     <a:solidFill>
-                      <a:srgbClr val="FBF3EE"/>
+                      <a:srgbClr val="FAF4F2"/>
                     </a:solidFill>
                   </a:tcPr>
                 </a:tc>
@@ -18040,7 +18218,7 @@
                   </a:txBody>
                   <a:tcPr marL="109728" marR="109728" marT="45720" marB="45720" anchor="ctr">
                     <a:solidFill>
-                      <a:srgbClr val="FBF3EE"/>
+                      <a:srgbClr val="FAF4F2"/>
                     </a:solidFill>
                   </a:tcPr>
                 </a:tc>
@@ -18062,12 +18240,12 @@
                   </a:txBody>
                   <a:tcPr marL="109728" marR="109728" marT="45720" marB="45720" anchor="ctr">
                     <a:solidFill>
-                      <a:srgbClr val="FBF3EE"/>
+                      <a:srgbClr val="FAF4F2"/>
                     </a:solidFill>
                   </a:tcPr>
                 </a:tc>
               </a:tr>
-              <a:tr h="777240">
+              <a:tr h="640080">
                 <a:tc>
                   <a:txBody>
                     <a:bodyPr/>
@@ -18224,7 +18402,7 @@
           </a:fontRef>
         </p:style>
         <p:txBody>
-          <a:bodyPr rtlCol="0" anchor="ctr" lIns="0" rIns="0"/>
+          <a:bodyPr rtlCol="0" anchor="ctr" lIns="0" rIns="0" tIns="0" bIns="0"/>
           <a:lstStyle/>
           <a:p>
             <a:pPr algn="ctr"/>
@@ -18410,8 +18588,8 @@
           <p:nvPr/>
         </p:nvGraphicFramePr>
         <p:xfrm>
-          <a:off x="548640" y="1600200"/>
-          <a:ext cx="11094413" cy="4526277"/>
+          <a:off x="548640" y="1554480"/>
+          <a:ext cx="11094413" cy="4480560"/>
         </p:xfrm>
         <a:graphic>
           <a:graphicData uri="http://schemas.openxmlformats.org/drawingml/2006/table">
@@ -18426,14 +18604,14 @@
                 <a:gridCol w="1528312"/>
                 <a:gridCol w="1528312"/>
               </a:tblGrid>
-              <a:tr h="646611">
+              <a:tr h="640080">
                 <a:tc>
                   <a:txBody>
                     <a:bodyPr/>
                     <a:lstStyle/>
                     <a:p>
                       <a:r>
-                        <a:rPr sz="1700" i="0" b="1">
+                        <a:rPr sz="1500" i="0" b="1">
                           <a:solidFill>
                             <a:srgbClr val="FFFFFF"/>
                           </a:solidFill>
@@ -18455,7 +18633,7 @@
                     <a:lstStyle/>
                     <a:p>
                       <a:r>
-                        <a:rPr sz="1700" i="0" b="1">
+                        <a:rPr sz="1500" i="0" b="1">
                           <a:solidFill>
                             <a:srgbClr val="FFFFFF"/>
                           </a:solidFill>
@@ -18477,7 +18655,7 @@
                     <a:lstStyle/>
                     <a:p>
                       <a:r>
-                        <a:rPr sz="1700" i="0" b="1">
+                        <a:rPr sz="1500" i="0" b="1">
                           <a:solidFill>
                             <a:srgbClr val="FFFFFF"/>
                           </a:solidFill>
@@ -18499,7 +18677,7 @@
                     <a:lstStyle/>
                     <a:p>
                       <a:r>
-                        <a:rPr sz="1700" i="0" b="1">
+                        <a:rPr sz="1500" i="0" b="1">
                           <a:solidFill>
                             <a:srgbClr val="FFFFFF"/>
                           </a:solidFill>
@@ -18521,7 +18699,7 @@
                     <a:lstStyle/>
                     <a:p>
                       <a:r>
-                        <a:rPr sz="1700" i="0" b="1">
+                        <a:rPr sz="1500" i="0" b="1">
                           <a:solidFill>
                             <a:srgbClr val="FFFFFF"/>
                           </a:solidFill>
@@ -18538,14 +18716,14 @@
                   </a:tcPr>
                 </a:tc>
               </a:tr>
-              <a:tr h="646611">
+              <a:tr h="640080">
                 <a:tc>
                   <a:txBody>
                     <a:bodyPr/>
                     <a:lstStyle/>
                     <a:p>
                       <a:r>
-                        <a:rPr sz="1800" i="0" b="1">
+                        <a:rPr sz="1600" i="0" b="1">
                           <a:solidFill>
                             <a:srgbClr val="2B211C"/>
                           </a:solidFill>
@@ -18567,7 +18745,7 @@
                     <a:lstStyle/>
                     <a:p>
                       <a:r>
-                        <a:rPr sz="1800" i="0" b="0">
+                        <a:rPr sz="1600" i="0" b="0">
                           <a:solidFill>
                             <a:srgbClr val="2B211C"/>
                           </a:solidFill>
@@ -18589,7 +18767,7 @@
                     <a:lstStyle/>
                     <a:p>
                       <a:r>
-                        <a:rPr sz="1800" i="0" b="0">
+                        <a:rPr sz="1600" i="0" b="0">
                           <a:solidFill>
                             <a:srgbClr val="2B211C"/>
                           </a:solidFill>
@@ -18611,7 +18789,7 @@
                     <a:lstStyle/>
                     <a:p>
                       <a:r>
-                        <a:rPr sz="1800" i="0" b="0">
+                        <a:rPr sz="1600" i="0" b="0">
                           <a:solidFill>
                             <a:srgbClr val="2B211C"/>
                           </a:solidFill>
@@ -18633,7 +18811,7 @@
                     <a:lstStyle/>
                     <a:p>
                       <a:r>
-                        <a:rPr sz="1800" i="0" b="0">
+                        <a:rPr sz="1600" i="0" b="0">
                           <a:solidFill>
                             <a:srgbClr val="2B211C"/>
                           </a:solidFill>
@@ -18650,14 +18828,14 @@
                   </a:tcPr>
                 </a:tc>
               </a:tr>
-              <a:tr h="646611">
+              <a:tr h="640080">
                 <a:tc>
                   <a:txBody>
                     <a:bodyPr/>
                     <a:lstStyle/>
                     <a:p>
                       <a:r>
-                        <a:rPr sz="1800" i="0" b="1">
+                        <a:rPr sz="1600" i="0" b="1">
                           <a:solidFill>
                             <a:srgbClr val="2B211C"/>
                           </a:solidFill>
@@ -18669,7 +18847,7 @@
                   </a:txBody>
                   <a:tcPr marL="109728" marR="109728" marT="45720" marB="45720" anchor="ctr">
                     <a:solidFill>
-                      <a:srgbClr val="FBF3EE"/>
+                      <a:srgbClr val="FAF4F2"/>
                     </a:solidFill>
                   </a:tcPr>
                 </a:tc>
@@ -18679,7 +18857,7 @@
                     <a:lstStyle/>
                     <a:p>
                       <a:r>
-                        <a:rPr sz="1800" i="0" b="0">
+                        <a:rPr sz="1600" i="0" b="0">
                           <a:solidFill>
                             <a:srgbClr val="2B211C"/>
                           </a:solidFill>
@@ -18691,7 +18869,7 @@
                   </a:txBody>
                   <a:tcPr marL="109728" marR="109728" marT="45720" marB="45720" anchor="ctr">
                     <a:solidFill>
-                      <a:srgbClr val="FBF3EE"/>
+                      <a:srgbClr val="FAF4F2"/>
                     </a:solidFill>
                   </a:tcPr>
                 </a:tc>
@@ -18701,7 +18879,7 @@
                     <a:lstStyle/>
                     <a:p>
                       <a:r>
-                        <a:rPr sz="1800" i="0" b="0">
+                        <a:rPr sz="1600" i="0" b="0">
                           <a:solidFill>
                             <a:srgbClr val="2B211C"/>
                           </a:solidFill>
@@ -18713,7 +18891,7 @@
                   </a:txBody>
                   <a:tcPr marL="109728" marR="109728" marT="45720" marB="45720" anchor="ctr">
                     <a:solidFill>
-                      <a:srgbClr val="FBF3EE"/>
+                      <a:srgbClr val="FAF4F2"/>
                     </a:solidFill>
                   </a:tcPr>
                 </a:tc>
@@ -18723,7 +18901,7 @@
                     <a:lstStyle/>
                     <a:p>
                       <a:r>
-                        <a:rPr sz="1800" i="0" b="0">
+                        <a:rPr sz="1600" i="0" b="0">
                           <a:solidFill>
                             <a:srgbClr val="2B211C"/>
                           </a:solidFill>
@@ -18735,7 +18913,7 @@
                   </a:txBody>
                   <a:tcPr marL="109728" marR="109728" marT="45720" marB="45720" anchor="ctr">
                     <a:solidFill>
-                      <a:srgbClr val="FBF3EE"/>
+                      <a:srgbClr val="FAF4F2"/>
                     </a:solidFill>
                   </a:tcPr>
                 </a:tc>
@@ -18745,7 +18923,7 @@
                     <a:lstStyle/>
                     <a:p>
                       <a:r>
-                        <a:rPr sz="1800" i="0" b="0">
+                        <a:rPr sz="1600" i="0" b="0">
                           <a:solidFill>
                             <a:srgbClr val="2B211C"/>
                           </a:solidFill>
@@ -18757,19 +18935,19 @@
                   </a:txBody>
                   <a:tcPr marL="109728" marR="109728" marT="45720" marB="45720" anchor="ctr">
                     <a:solidFill>
-                      <a:srgbClr val="FBF3EE"/>
+                      <a:srgbClr val="FAF4F2"/>
                     </a:solidFill>
                   </a:tcPr>
                 </a:tc>
               </a:tr>
-              <a:tr h="646611">
+              <a:tr h="640080">
                 <a:tc>
                   <a:txBody>
                     <a:bodyPr/>
                     <a:lstStyle/>
                     <a:p>
                       <a:r>
-                        <a:rPr sz="1800" i="0" b="1">
+                        <a:rPr sz="1600" i="0" b="1">
                           <a:solidFill>
                             <a:srgbClr val="2B211C"/>
                           </a:solidFill>
@@ -18791,7 +18969,7 @@
                     <a:lstStyle/>
                     <a:p>
                       <a:r>
-                        <a:rPr sz="1800" i="0" b="0">
+                        <a:rPr sz="1600" i="0" b="0">
                           <a:solidFill>
                             <a:srgbClr val="2B211C"/>
                           </a:solidFill>
@@ -18813,7 +18991,7 @@
                     <a:lstStyle/>
                     <a:p>
                       <a:r>
-                        <a:rPr sz="1800" i="0" b="0">
+                        <a:rPr sz="1600" i="0" b="0">
                           <a:solidFill>
                             <a:srgbClr val="2B211C"/>
                           </a:solidFill>
@@ -18835,7 +19013,7 @@
                     <a:lstStyle/>
                     <a:p>
                       <a:r>
-                        <a:rPr sz="1800" i="0" b="0">
+                        <a:rPr sz="1600" i="0" b="0">
                           <a:solidFill>
                             <a:srgbClr val="2B211C"/>
                           </a:solidFill>
@@ -18857,7 +19035,7 @@
                     <a:lstStyle/>
                     <a:p>
                       <a:r>
-                        <a:rPr sz="1800" i="0" b="0">
+                        <a:rPr sz="1600" i="0" b="0">
                           <a:solidFill>
                             <a:srgbClr val="2B211C"/>
                           </a:solidFill>
@@ -18874,14 +19052,14 @@
                   </a:tcPr>
                 </a:tc>
               </a:tr>
-              <a:tr h="646611">
+              <a:tr h="640080">
                 <a:tc>
                   <a:txBody>
                     <a:bodyPr/>
                     <a:lstStyle/>
                     <a:p>
                       <a:r>
-                        <a:rPr sz="1800" i="0" b="1">
+                        <a:rPr sz="1600" i="0" b="1">
                           <a:solidFill>
                             <a:srgbClr val="2B211C"/>
                           </a:solidFill>
@@ -18893,7 +19071,7 @@
                   </a:txBody>
                   <a:tcPr marL="109728" marR="109728" marT="45720" marB="45720" anchor="ctr">
                     <a:solidFill>
-                      <a:srgbClr val="FBF3EE"/>
+                      <a:srgbClr val="FAF4F2"/>
                     </a:solidFill>
                   </a:tcPr>
                 </a:tc>
@@ -18903,7 +19081,7 @@
                     <a:lstStyle/>
                     <a:p>
                       <a:r>
-                        <a:rPr sz="1800" i="0" b="0">
+                        <a:rPr sz="1600" i="0" b="0">
                           <a:solidFill>
                             <a:srgbClr val="2B211C"/>
                           </a:solidFill>
@@ -18915,7 +19093,7 @@
                   </a:txBody>
                   <a:tcPr marL="109728" marR="109728" marT="45720" marB="45720" anchor="ctr">
                     <a:solidFill>
-                      <a:srgbClr val="FBF3EE"/>
+                      <a:srgbClr val="FAF4F2"/>
                     </a:solidFill>
                   </a:tcPr>
                 </a:tc>
@@ -18925,7 +19103,7 @@
                     <a:lstStyle/>
                     <a:p>
                       <a:r>
-                        <a:rPr sz="1800" i="0" b="0">
+                        <a:rPr sz="1600" i="0" b="0">
                           <a:solidFill>
                             <a:srgbClr val="2B211C"/>
                           </a:solidFill>
@@ -18937,7 +19115,7 @@
                   </a:txBody>
                   <a:tcPr marL="109728" marR="109728" marT="45720" marB="45720" anchor="ctr">
                     <a:solidFill>
-                      <a:srgbClr val="FBF3EE"/>
+                      <a:srgbClr val="FAF4F2"/>
                     </a:solidFill>
                   </a:tcPr>
                 </a:tc>
@@ -18947,7 +19125,7 @@
                     <a:lstStyle/>
                     <a:p>
                       <a:r>
-                        <a:rPr sz="1800" i="0" b="0">
+                        <a:rPr sz="1600" i="0" b="0">
                           <a:solidFill>
                             <a:srgbClr val="2B211C"/>
                           </a:solidFill>
@@ -18959,7 +19137,7 @@
                   </a:txBody>
                   <a:tcPr marL="109728" marR="109728" marT="45720" marB="45720" anchor="ctr">
                     <a:solidFill>
-                      <a:srgbClr val="FBF3EE"/>
+                      <a:srgbClr val="FAF4F2"/>
                     </a:solidFill>
                   </a:tcPr>
                 </a:tc>
@@ -18969,7 +19147,7 @@
                     <a:lstStyle/>
                     <a:p>
                       <a:r>
-                        <a:rPr sz="1800" i="0" b="0">
+                        <a:rPr sz="1600" i="0" b="0">
                           <a:solidFill>
                             <a:srgbClr val="2B211C"/>
                           </a:solidFill>
@@ -18981,19 +19159,19 @@
                   </a:txBody>
                   <a:tcPr marL="109728" marR="109728" marT="45720" marB="45720" anchor="ctr">
                     <a:solidFill>
-                      <a:srgbClr val="FBF3EE"/>
+                      <a:srgbClr val="FAF4F2"/>
                     </a:solidFill>
                   </a:tcPr>
                 </a:tc>
               </a:tr>
-              <a:tr h="646611">
+              <a:tr h="640080">
                 <a:tc>
                   <a:txBody>
                     <a:bodyPr/>
                     <a:lstStyle/>
                     <a:p>
                       <a:r>
-                        <a:rPr sz="1800" i="0" b="1">
+                        <a:rPr sz="1600" i="0" b="1">
                           <a:solidFill>
                             <a:srgbClr val="2B211C"/>
                           </a:solidFill>
@@ -19015,7 +19193,7 @@
                     <a:lstStyle/>
                     <a:p>
                       <a:r>
-                        <a:rPr sz="1800" i="0" b="0">
+                        <a:rPr sz="1600" i="0" b="0">
                           <a:solidFill>
                             <a:srgbClr val="2B211C"/>
                           </a:solidFill>
@@ -19068,14 +19246,14 @@
                   </a:tcPr>
                 </a:tc>
               </a:tr>
-              <a:tr h="646611">
+              <a:tr h="640080">
                 <a:tc>
                   <a:txBody>
                     <a:bodyPr/>
                     <a:lstStyle/>
                     <a:p>
                       <a:r>
-                        <a:rPr sz="1800" i="0" b="1">
+                        <a:rPr sz="1600" i="0" b="1">
                           <a:solidFill>
                             <a:srgbClr val="2B211C"/>
                           </a:solidFill>
@@ -19087,7 +19265,7 @@
                   </a:txBody>
                   <a:tcPr marL="109728" marR="109728" marT="45720" marB="45720" anchor="ctr">
                     <a:solidFill>
-                      <a:srgbClr val="FBF3EE"/>
+                      <a:srgbClr val="FAF4F2"/>
                     </a:solidFill>
                   </a:tcPr>
                 </a:tc>
@@ -19097,7 +19275,7 @@
                     <a:lstStyle/>
                     <a:p>
                       <a:r>
-                        <a:rPr sz="1800" i="0" b="0">
+                        <a:rPr sz="1600" i="0" b="0">
                           <a:solidFill>
                             <a:srgbClr val="2B211C"/>
                           </a:solidFill>
@@ -19109,7 +19287,7 @@
                   </a:txBody>
                   <a:tcPr marL="109728" marR="109728" marT="45720" marB="45720" anchor="ctr">
                     <a:solidFill>
-                      <a:srgbClr val="FBF3EE"/>
+                      <a:srgbClr val="FAF4F2"/>
                     </a:solidFill>
                   </a:tcPr>
                 </a:tc>
@@ -19121,7 +19299,7 @@
                   </a:txBody>
                   <a:tcPr marL="109728" marR="109728" marT="45720" marB="45720" anchor="ctr">
                     <a:solidFill>
-                      <a:srgbClr val="FBF3EE"/>
+                      <a:srgbClr val="FAF4F2"/>
                     </a:solidFill>
                   </a:tcPr>
                 </a:tc>
@@ -19133,7 +19311,7 @@
                   </a:txBody>
                   <a:tcPr marL="109728" marR="109728" marT="45720" marB="45720" anchor="ctr">
                     <a:solidFill>
-                      <a:srgbClr val="FBF3EE"/>
+                      <a:srgbClr val="FAF4F2"/>
                     </a:solidFill>
                   </a:tcPr>
                 </a:tc>
@@ -19145,7 +19323,7 @@
                   </a:txBody>
                   <a:tcPr marL="109728" marR="109728" marT="45720" marB="45720" anchor="ctr">
                     <a:solidFill>
-                      <a:srgbClr val="FBF3EE"/>
+                      <a:srgbClr val="FAF4F2"/>
                     </a:solidFill>
                   </a:tcPr>
                 </a:tc>
@@ -19217,7 +19395,7 @@
           </a:fontRef>
         </p:style>
         <p:txBody>
-          <a:bodyPr rtlCol="0" anchor="ctr" lIns="0" rIns="0"/>
+          <a:bodyPr rtlCol="0" anchor="ctr" lIns="0" rIns="0" tIns="0" bIns="0"/>
           <a:lstStyle/>
           <a:p>
             <a:pPr algn="ctr"/>
@@ -19394,17 +19572,56 @@
           </a:prstGeom>
         </p:spPr>
       </p:pic>
+      <p:sp>
+        <p:nvSpPr>
+          <p:cNvPr id="8" name="TextBox 7"/>
+          <p:cNvSpPr txBox="1"/>
+          <p:nvPr/>
+        </p:nvSpPr>
+        <p:spPr>
+          <a:xfrm>
+            <a:off x="548640" y="1554480"/>
+            <a:ext cx="11094415" cy="498348"/>
+          </a:xfrm>
+          <a:prstGeom prst="rect">
+            <a:avLst/>
+          </a:prstGeom>
+          <a:noFill/>
+        </p:spPr>
+        <p:txBody>
+          <a:bodyPr wrap="square" anchor="t" lIns="0" rIns="0" tIns="0" bIns="0">
+            <a:spAutoFit/>
+          </a:bodyPr>
+          <a:lstStyle/>
+          <a:p>
+            <a:pPr>
+              <a:spcAft>
+                <a:spcPts val="800"/>
+              </a:spcAft>
+            </a:pPr>
+            <a:r>
+              <a:rPr sz="1800" i="0" b="0">
+                <a:solidFill>
+                  <a:srgbClr val="2B211C"/>
+                </a:solidFill>
+                <a:latin typeface="Calibri"/>
+              </a:rPr>
+              <a:t>The Naranjo algorithm asks ten questions. Add the scores for the answers.</a:t>
+            </a:r>
+          </a:p>
+        </p:txBody>
+      </p:sp>
       <p:graphicFrame>
         <p:nvGraphicFramePr>
-          <p:cNvPr id="8" name="Table 7"/>
+          <p:cNvPr id="9" name="Table 8"/>
           <p:cNvGraphicFramePr>
             <a:graphicFrameLocks noGrp="1"/>
           </p:cNvGraphicFramePr>
           <p:nvPr/>
         </p:nvGraphicFramePr>
         <p:xfrm>
-          <a:off x="548640" y="1600200"/>
-          <a:ext cx="11094412" cy="4526280"/>
+          <a:off x="548640" y="2235708"/>
+          <a:ext cx="11094412" cy="3936482"/>
         </p:xfrm>
         <a:graphic>
           <a:graphicData uri="http://schemas.openxmlformats.org/drawingml/2006/table">
@@ -19419,14 +19636,14 @@
                 <a:gridCol w="940204"/>
                 <a:gridCol w="1786388"/>
               </a:tblGrid>
-              <a:tr h="411480">
+              <a:tr h="357862">
                 <a:tc>
                   <a:txBody>
                     <a:bodyPr/>
                     <a:lstStyle/>
                     <a:p>
                       <a:r>
-                        <a:rPr sz="1500" i="0" b="1">
+                        <a:rPr sz="1000" i="0" b="1">
                           <a:solidFill>
                             <a:srgbClr val="FFFFFF"/>
                           </a:solidFill>
@@ -19448,7 +19665,7 @@
                     <a:lstStyle/>
                     <a:p>
                       <a:r>
-                        <a:rPr sz="1500" i="0" b="1">
+                        <a:rPr sz="1000" i="0" b="1">
                           <a:solidFill>
                             <a:srgbClr val="FFFFFF"/>
                           </a:solidFill>
@@ -19470,7 +19687,7 @@
                     <a:lstStyle/>
                     <a:p>
                       <a:r>
-                        <a:rPr sz="1500" i="0" b="1">
+                        <a:rPr sz="1000" i="0" b="1">
                           <a:solidFill>
                             <a:srgbClr val="FFFFFF"/>
                           </a:solidFill>
@@ -19492,7 +19709,7 @@
                     <a:lstStyle/>
                     <a:p>
                       <a:r>
-                        <a:rPr sz="1500" i="0" b="1">
+                        <a:rPr sz="1000" i="0" b="1">
                           <a:solidFill>
                             <a:srgbClr val="FFFFFF"/>
                           </a:solidFill>
@@ -19514,7 +19731,7 @@
                     <a:lstStyle/>
                     <a:p>
                       <a:r>
-                        <a:rPr sz="1500" i="0" b="1">
+                        <a:rPr sz="1000" i="0" b="1">
                           <a:solidFill>
                             <a:srgbClr val="FFFFFF"/>
                           </a:solidFill>
@@ -19531,14 +19748,14 @@
                   </a:tcPr>
                 </a:tc>
               </a:tr>
-              <a:tr h="411480">
+              <a:tr h="357862">
                 <a:tc>
                   <a:txBody>
                     <a:bodyPr/>
                     <a:lstStyle/>
                     <a:p>
                       <a:r>
-                        <a:rPr sz="1600" i="0" b="1">
+                        <a:rPr sz="1100" i="0" b="1">
                           <a:solidFill>
                             <a:srgbClr val="2B211C"/>
                           </a:solidFill>
@@ -19560,7 +19777,7 @@
                     <a:lstStyle/>
                     <a:p>
                       <a:r>
-                        <a:rPr sz="1600" i="0" b="0">
+                        <a:rPr sz="1100" i="0" b="0">
                           <a:solidFill>
                             <a:srgbClr val="2B211C"/>
                           </a:solidFill>
@@ -19582,7 +19799,7 @@
                     <a:lstStyle/>
                     <a:p>
                       <a:r>
-                        <a:rPr sz="1600" i="0" b="0">
+                        <a:rPr sz="1100" i="0" b="0">
                           <a:solidFill>
                             <a:srgbClr val="2B211C"/>
                           </a:solidFill>
@@ -19604,7 +19821,7 @@
                     <a:lstStyle/>
                     <a:p>
                       <a:r>
-                        <a:rPr sz="1600" i="0" b="0">
+                        <a:rPr sz="1100" i="0" b="0">
                           <a:solidFill>
                             <a:srgbClr val="2B211C"/>
                           </a:solidFill>
@@ -19626,7 +19843,7 @@
                     <a:lstStyle/>
                     <a:p>
                       <a:r>
-                        <a:rPr sz="1600" i="0" b="0">
+                        <a:rPr sz="1100" i="0" b="0">
                           <a:solidFill>
                             <a:srgbClr val="2B211C"/>
                           </a:solidFill>
@@ -19643,14 +19860,14 @@
                   </a:tcPr>
                 </a:tc>
               </a:tr>
-              <a:tr h="411480">
+              <a:tr h="357862">
                 <a:tc>
                   <a:txBody>
                     <a:bodyPr/>
                     <a:lstStyle/>
                     <a:p>
                       <a:r>
-                        <a:rPr sz="1600" i="0" b="1">
+                        <a:rPr sz="1100" i="0" b="1">
                           <a:solidFill>
                             <a:srgbClr val="2B211C"/>
                           </a:solidFill>
@@ -19662,7 +19879,7 @@
                   </a:txBody>
                   <a:tcPr marL="109728" marR="109728" marT="45720" marB="45720" anchor="ctr">
                     <a:solidFill>
-                      <a:srgbClr val="FBF3EE"/>
+                      <a:srgbClr val="FAF4F2"/>
                     </a:solidFill>
                   </a:tcPr>
                 </a:tc>
@@ -19672,7 +19889,7 @@
                     <a:lstStyle/>
                     <a:p>
                       <a:r>
-                        <a:rPr sz="1600" i="0" b="0">
+                        <a:rPr sz="1100" i="0" b="0">
                           <a:solidFill>
                             <a:srgbClr val="2B211C"/>
                           </a:solidFill>
@@ -19684,7 +19901,7 @@
                   </a:txBody>
                   <a:tcPr marL="109728" marR="109728" marT="45720" marB="45720" anchor="ctr">
                     <a:solidFill>
-                      <a:srgbClr val="FBF3EE"/>
+                      <a:srgbClr val="FAF4F2"/>
                     </a:solidFill>
                   </a:tcPr>
                 </a:tc>
@@ -19694,7 +19911,7 @@
                     <a:lstStyle/>
                     <a:p>
                       <a:r>
-                        <a:rPr sz="1600" i="0" b="0">
+                        <a:rPr sz="1100" i="0" b="0">
                           <a:solidFill>
                             <a:srgbClr val="2B211C"/>
                           </a:solidFill>
@@ -19706,7 +19923,7 @@
                   </a:txBody>
                   <a:tcPr marL="109728" marR="109728" marT="45720" marB="45720" anchor="ctr">
                     <a:solidFill>
-                      <a:srgbClr val="FBF3EE"/>
+                      <a:srgbClr val="FAF4F2"/>
                     </a:solidFill>
                   </a:tcPr>
                 </a:tc>
@@ -19716,7 +19933,7 @@
                     <a:lstStyle/>
                     <a:p>
                       <a:r>
-                        <a:rPr sz="1600" i="0" b="0">
+                        <a:rPr sz="1100" i="0" b="0">
                           <a:solidFill>
                             <a:srgbClr val="2B211C"/>
                           </a:solidFill>
@@ -19728,7 +19945,7 @@
                   </a:txBody>
                   <a:tcPr marL="109728" marR="109728" marT="45720" marB="45720" anchor="ctr">
                     <a:solidFill>
-                      <a:srgbClr val="FBF3EE"/>
+                      <a:srgbClr val="FAF4F2"/>
                     </a:solidFill>
                   </a:tcPr>
                 </a:tc>
@@ -19738,7 +19955,7 @@
                     <a:lstStyle/>
                     <a:p>
                       <a:r>
-                        <a:rPr sz="1600" i="0" b="0">
+                        <a:rPr sz="1100" i="0" b="0">
                           <a:solidFill>
                             <a:srgbClr val="2B211C"/>
                           </a:solidFill>
@@ -19750,19 +19967,19 @@
                   </a:txBody>
                   <a:tcPr marL="109728" marR="109728" marT="45720" marB="45720" anchor="ctr">
                     <a:solidFill>
-                      <a:srgbClr val="FBF3EE"/>
+                      <a:srgbClr val="FAF4F2"/>
                     </a:solidFill>
                   </a:tcPr>
                 </a:tc>
               </a:tr>
-              <a:tr h="411480">
+              <a:tr h="357862">
                 <a:tc>
                   <a:txBody>
                     <a:bodyPr/>
                     <a:lstStyle/>
                     <a:p>
                       <a:r>
-                        <a:rPr sz="1600" i="0" b="1">
+                        <a:rPr sz="1100" i="0" b="1">
                           <a:solidFill>
                             <a:srgbClr val="2B211C"/>
                           </a:solidFill>
@@ -19784,7 +20001,7 @@
                     <a:lstStyle/>
                     <a:p>
                       <a:r>
-                        <a:rPr sz="1600" i="0" b="0">
+                        <a:rPr sz="1100" i="0" b="0">
                           <a:solidFill>
                             <a:srgbClr val="2B211C"/>
                           </a:solidFill>
@@ -19806,7 +20023,7 @@
                     <a:lstStyle/>
                     <a:p>
                       <a:r>
-                        <a:rPr sz="1600" i="0" b="0">
+                        <a:rPr sz="1100" i="0" b="0">
                           <a:solidFill>
                             <a:srgbClr val="2B211C"/>
                           </a:solidFill>
@@ -19828,7 +20045,7 @@
                     <a:lstStyle/>
                     <a:p>
                       <a:r>
-                        <a:rPr sz="1600" i="0" b="0">
+                        <a:rPr sz="1100" i="0" b="0">
                           <a:solidFill>
                             <a:srgbClr val="2B211C"/>
                           </a:solidFill>
@@ -19850,7 +20067,7 @@
                     <a:lstStyle/>
                     <a:p>
                       <a:r>
-                        <a:rPr sz="1600" i="0" b="0">
+                        <a:rPr sz="1100" i="0" b="0">
                           <a:solidFill>
                             <a:srgbClr val="2B211C"/>
                           </a:solidFill>
@@ -19867,14 +20084,14 @@
                   </a:tcPr>
                 </a:tc>
               </a:tr>
-              <a:tr h="411480">
+              <a:tr h="357862">
                 <a:tc>
                   <a:txBody>
                     <a:bodyPr/>
                     <a:lstStyle/>
                     <a:p>
                       <a:r>
-                        <a:rPr sz="1600" i="0" b="1">
+                        <a:rPr sz="1100" i="0" b="1">
                           <a:solidFill>
                             <a:srgbClr val="2B211C"/>
                           </a:solidFill>
@@ -19886,7 +20103,7 @@
                   </a:txBody>
                   <a:tcPr marL="109728" marR="109728" marT="45720" marB="45720" anchor="ctr">
                     <a:solidFill>
-                      <a:srgbClr val="FBF3EE"/>
+                      <a:srgbClr val="FAF4F2"/>
                     </a:solidFill>
                   </a:tcPr>
                 </a:tc>
@@ -19896,7 +20113,7 @@
                     <a:lstStyle/>
                     <a:p>
                       <a:r>
-                        <a:rPr sz="1600" i="0" b="0">
+                        <a:rPr sz="1100" i="0" b="0">
                           <a:solidFill>
                             <a:srgbClr val="2B211C"/>
                           </a:solidFill>
@@ -19908,7 +20125,7 @@
                   </a:txBody>
                   <a:tcPr marL="109728" marR="109728" marT="45720" marB="45720" anchor="ctr">
                     <a:solidFill>
-                      <a:srgbClr val="FBF3EE"/>
+                      <a:srgbClr val="FAF4F2"/>
                     </a:solidFill>
                   </a:tcPr>
                 </a:tc>
@@ -19918,7 +20135,7 @@
                     <a:lstStyle/>
                     <a:p>
                       <a:r>
-                        <a:rPr sz="1600" i="0" b="0">
+                        <a:rPr sz="1100" i="0" b="0">
                           <a:solidFill>
                             <a:srgbClr val="2B211C"/>
                           </a:solidFill>
@@ -19930,7 +20147,7 @@
                   </a:txBody>
                   <a:tcPr marL="109728" marR="109728" marT="45720" marB="45720" anchor="ctr">
                     <a:solidFill>
-                      <a:srgbClr val="FBF3EE"/>
+                      <a:srgbClr val="FAF4F2"/>
                     </a:solidFill>
                   </a:tcPr>
                 </a:tc>
@@ -19940,7 +20157,7 @@
                     <a:lstStyle/>
                     <a:p>
                       <a:r>
-                        <a:rPr sz="1600" i="0" b="0">
+                        <a:rPr sz="1100" i="0" b="0">
                           <a:solidFill>
                             <a:srgbClr val="2B211C"/>
                           </a:solidFill>
@@ -19952,7 +20169,7 @@
                   </a:txBody>
                   <a:tcPr marL="109728" marR="109728" marT="45720" marB="45720" anchor="ctr">
                     <a:solidFill>
-                      <a:srgbClr val="FBF3EE"/>
+                      <a:srgbClr val="FAF4F2"/>
                     </a:solidFill>
                   </a:tcPr>
                 </a:tc>
@@ -19962,7 +20179,7 @@
                     <a:lstStyle/>
                     <a:p>
                       <a:r>
-                        <a:rPr sz="1600" i="0" b="0">
+                        <a:rPr sz="1100" i="0" b="0">
                           <a:solidFill>
                             <a:srgbClr val="2B211C"/>
                           </a:solidFill>
@@ -19974,19 +20191,19 @@
                   </a:txBody>
                   <a:tcPr marL="109728" marR="109728" marT="45720" marB="45720" anchor="ctr">
                     <a:solidFill>
-                      <a:srgbClr val="FBF3EE"/>
+                      <a:srgbClr val="FAF4F2"/>
                     </a:solidFill>
                   </a:tcPr>
                 </a:tc>
               </a:tr>
-              <a:tr h="411480">
+              <a:tr h="357862">
                 <a:tc>
                   <a:txBody>
                     <a:bodyPr/>
                     <a:lstStyle/>
                     <a:p>
                       <a:r>
-                        <a:rPr sz="1600" i="0" b="1">
+                        <a:rPr sz="1100" i="0" b="1">
                           <a:solidFill>
                             <a:srgbClr val="2B211C"/>
                           </a:solidFill>
@@ -20008,7 +20225,7 @@
                     <a:lstStyle/>
                     <a:p>
                       <a:r>
-                        <a:rPr sz="1600" i="0" b="0">
+                        <a:rPr sz="1100" i="0" b="0">
                           <a:solidFill>
                             <a:srgbClr val="2B211C"/>
                           </a:solidFill>
@@ -20030,7 +20247,7 @@
                     <a:lstStyle/>
                     <a:p>
                       <a:r>
-                        <a:rPr sz="1600" i="0" b="0">
+                        <a:rPr sz="1100" i="0" b="0">
                           <a:solidFill>
                             <a:srgbClr val="2B211C"/>
                           </a:solidFill>
@@ -20052,7 +20269,7 @@
                     <a:lstStyle/>
                     <a:p>
                       <a:r>
-                        <a:rPr sz="1600" i="0" b="0">
+                        <a:rPr sz="1100" i="0" b="0">
                           <a:solidFill>
                             <a:srgbClr val="2B211C"/>
                           </a:solidFill>
@@ -20074,7 +20291,7 @@
                     <a:lstStyle/>
                     <a:p>
                       <a:r>
-                        <a:rPr sz="1600" i="0" b="0">
+                        <a:rPr sz="1100" i="0" b="0">
                           <a:solidFill>
                             <a:srgbClr val="2B211C"/>
                           </a:solidFill>
@@ -20091,14 +20308,14 @@
                   </a:tcPr>
                 </a:tc>
               </a:tr>
-              <a:tr h="411480">
+              <a:tr h="357862">
                 <a:tc>
                   <a:txBody>
                     <a:bodyPr/>
                     <a:lstStyle/>
                     <a:p>
                       <a:r>
-                        <a:rPr sz="1600" i="0" b="1">
+                        <a:rPr sz="1100" i="0" b="1">
                           <a:solidFill>
                             <a:srgbClr val="2B211C"/>
                           </a:solidFill>
@@ -20110,7 +20327,7 @@
                   </a:txBody>
                   <a:tcPr marL="109728" marR="109728" marT="45720" marB="45720" anchor="ctr">
                     <a:solidFill>
-                      <a:srgbClr val="FBF3EE"/>
+                      <a:srgbClr val="FAF4F2"/>
                     </a:solidFill>
                   </a:tcPr>
                 </a:tc>
@@ -20120,7 +20337,7 @@
                     <a:lstStyle/>
                     <a:p>
                       <a:r>
-                        <a:rPr sz="1600" i="0" b="0">
+                        <a:rPr sz="1100" i="0" b="0">
                           <a:solidFill>
                             <a:srgbClr val="2B211C"/>
                           </a:solidFill>
@@ -20132,7 +20349,7 @@
                   </a:txBody>
                   <a:tcPr marL="109728" marR="109728" marT="45720" marB="45720" anchor="ctr">
                     <a:solidFill>
-                      <a:srgbClr val="FBF3EE"/>
+                      <a:srgbClr val="FAF4F2"/>
                     </a:solidFill>
                   </a:tcPr>
                 </a:tc>
@@ -20142,7 +20359,7 @@
                     <a:lstStyle/>
                     <a:p>
                       <a:r>
-                        <a:rPr sz="1600" i="0" b="0">
+                        <a:rPr sz="1100" i="0" b="0">
                           <a:solidFill>
                             <a:srgbClr val="2B211C"/>
                           </a:solidFill>
@@ -20154,7 +20371,7 @@
                   </a:txBody>
                   <a:tcPr marL="109728" marR="109728" marT="45720" marB="45720" anchor="ctr">
                     <a:solidFill>
-                      <a:srgbClr val="FBF3EE"/>
+                      <a:srgbClr val="FAF4F2"/>
                     </a:solidFill>
                   </a:tcPr>
                 </a:tc>
@@ -20164,7 +20381,7 @@
                     <a:lstStyle/>
                     <a:p>
                       <a:r>
-                        <a:rPr sz="1600" i="0" b="0">
+                        <a:rPr sz="1100" i="0" b="0">
                           <a:solidFill>
                             <a:srgbClr val="2B211C"/>
                           </a:solidFill>
@@ -20176,7 +20393,7 @@
                   </a:txBody>
                   <a:tcPr marL="109728" marR="109728" marT="45720" marB="45720" anchor="ctr">
                     <a:solidFill>
-                      <a:srgbClr val="FBF3EE"/>
+                      <a:srgbClr val="FAF4F2"/>
                     </a:solidFill>
                   </a:tcPr>
                 </a:tc>
@@ -20186,7 +20403,7 @@
                     <a:lstStyle/>
                     <a:p>
                       <a:r>
-                        <a:rPr sz="1600" i="0" b="0">
+                        <a:rPr sz="1100" i="0" b="0">
                           <a:solidFill>
                             <a:srgbClr val="2B211C"/>
                           </a:solidFill>
@@ -20198,19 +20415,19 @@
                   </a:txBody>
                   <a:tcPr marL="109728" marR="109728" marT="45720" marB="45720" anchor="ctr">
                     <a:solidFill>
-                      <a:srgbClr val="FBF3EE"/>
+                      <a:srgbClr val="FAF4F2"/>
                     </a:solidFill>
                   </a:tcPr>
                 </a:tc>
               </a:tr>
-              <a:tr h="411480">
+              <a:tr h="357862">
                 <a:tc>
                   <a:txBody>
                     <a:bodyPr/>
                     <a:lstStyle/>
                     <a:p>
                       <a:r>
-                        <a:rPr sz="1600" i="0" b="1">
+                        <a:rPr sz="1100" i="0" b="1">
                           <a:solidFill>
                             <a:srgbClr val="2B211C"/>
                           </a:solidFill>
@@ -20232,7 +20449,7 @@
                     <a:lstStyle/>
                     <a:p>
                       <a:r>
-                        <a:rPr sz="1600" i="0" b="0">
+                        <a:rPr sz="1100" i="0" b="0">
                           <a:solidFill>
                             <a:srgbClr val="2B211C"/>
                           </a:solidFill>
@@ -20254,7 +20471,7 @@
                     <a:lstStyle/>
                     <a:p>
                       <a:r>
-                        <a:rPr sz="1600" i="0" b="0">
+                        <a:rPr sz="1100" i="0" b="0">
                           <a:solidFill>
                             <a:srgbClr val="2B211C"/>
                           </a:solidFill>
@@ -20276,7 +20493,7 @@
                     <a:lstStyle/>
                     <a:p>
                       <a:r>
-                        <a:rPr sz="1600" i="0" b="0">
+                        <a:rPr sz="1100" i="0" b="0">
                           <a:solidFill>
                             <a:srgbClr val="2B211C"/>
                           </a:solidFill>
@@ -20298,7 +20515,7 @@
                     <a:lstStyle/>
                     <a:p>
                       <a:r>
-                        <a:rPr sz="1600" i="0" b="0">
+                        <a:rPr sz="1100" i="0" b="0">
                           <a:solidFill>
                             <a:srgbClr val="2B211C"/>
                           </a:solidFill>
@@ -20315,14 +20532,14 @@
                   </a:tcPr>
                 </a:tc>
               </a:tr>
-              <a:tr h="411480">
+              <a:tr h="357862">
                 <a:tc>
                   <a:txBody>
                     <a:bodyPr/>
                     <a:lstStyle/>
                     <a:p>
                       <a:r>
-                        <a:rPr sz="1600" i="0" b="1">
+                        <a:rPr sz="1100" i="0" b="1">
                           <a:solidFill>
                             <a:srgbClr val="2B211C"/>
                           </a:solidFill>
@@ -20334,7 +20551,7 @@
                   </a:txBody>
                   <a:tcPr marL="109728" marR="109728" marT="45720" marB="45720" anchor="ctr">
                     <a:solidFill>
-                      <a:srgbClr val="FBF3EE"/>
+                      <a:srgbClr val="FAF4F2"/>
                     </a:solidFill>
                   </a:tcPr>
                 </a:tc>
@@ -20344,7 +20561,7 @@
                     <a:lstStyle/>
                     <a:p>
                       <a:r>
-                        <a:rPr sz="1600" i="0" b="0">
+                        <a:rPr sz="1100" i="0" b="0">
                           <a:solidFill>
                             <a:srgbClr val="2B211C"/>
                           </a:solidFill>
@@ -20356,7 +20573,7 @@
                   </a:txBody>
                   <a:tcPr marL="109728" marR="109728" marT="45720" marB="45720" anchor="ctr">
                     <a:solidFill>
-                      <a:srgbClr val="FBF3EE"/>
+                      <a:srgbClr val="FAF4F2"/>
                     </a:solidFill>
                   </a:tcPr>
                 </a:tc>
@@ -20366,7 +20583,7 @@
                     <a:lstStyle/>
                     <a:p>
                       <a:r>
-                        <a:rPr sz="1600" i="0" b="0">
+                        <a:rPr sz="1100" i="0" b="0">
                           <a:solidFill>
                             <a:srgbClr val="2B211C"/>
                           </a:solidFill>
@@ -20378,7 +20595,7 @@
                   </a:txBody>
                   <a:tcPr marL="109728" marR="109728" marT="45720" marB="45720" anchor="ctr">
                     <a:solidFill>
-                      <a:srgbClr val="FBF3EE"/>
+                      <a:srgbClr val="FAF4F2"/>
                     </a:solidFill>
                   </a:tcPr>
                 </a:tc>
@@ -20388,7 +20605,7 @@
                     <a:lstStyle/>
                     <a:p>
                       <a:r>
-                        <a:rPr sz="1600" i="0" b="0">
+                        <a:rPr sz="1100" i="0" b="0">
                           <a:solidFill>
                             <a:srgbClr val="2B211C"/>
                           </a:solidFill>
@@ -20400,7 +20617,7 @@
                   </a:txBody>
                   <a:tcPr marL="109728" marR="109728" marT="45720" marB="45720" anchor="ctr">
                     <a:solidFill>
-                      <a:srgbClr val="FBF3EE"/>
+                      <a:srgbClr val="FAF4F2"/>
                     </a:solidFill>
                   </a:tcPr>
                 </a:tc>
@@ -20410,7 +20627,7 @@
                     <a:lstStyle/>
                     <a:p>
                       <a:r>
-                        <a:rPr sz="1600" i="0" b="0">
+                        <a:rPr sz="1100" i="0" b="0">
                           <a:solidFill>
                             <a:srgbClr val="2B211C"/>
                           </a:solidFill>
@@ -20422,19 +20639,19 @@
                   </a:txBody>
                   <a:tcPr marL="109728" marR="109728" marT="45720" marB="45720" anchor="ctr">
                     <a:solidFill>
-                      <a:srgbClr val="FBF3EE"/>
+                      <a:srgbClr val="FAF4F2"/>
                     </a:solidFill>
                   </a:tcPr>
                 </a:tc>
               </a:tr>
-              <a:tr h="411480">
+              <a:tr h="357862">
                 <a:tc>
                   <a:txBody>
                     <a:bodyPr/>
                     <a:lstStyle/>
                     <a:p>
                       <a:r>
-                        <a:rPr sz="1600" i="0" b="1">
+                        <a:rPr sz="1100" i="0" b="1">
                           <a:solidFill>
                             <a:srgbClr val="2B211C"/>
                           </a:solidFill>
@@ -20456,7 +20673,7 @@
                     <a:lstStyle/>
                     <a:p>
                       <a:r>
-                        <a:rPr sz="1600" i="0" b="0">
+                        <a:rPr sz="1100" i="0" b="0">
                           <a:solidFill>
                             <a:srgbClr val="2B211C"/>
                           </a:solidFill>
@@ -20478,7 +20695,7 @@
                     <a:lstStyle/>
                     <a:p>
                       <a:r>
-                        <a:rPr sz="1600" i="0" b="0">
+                        <a:rPr sz="1100" i="0" b="0">
                           <a:solidFill>
                             <a:srgbClr val="2B211C"/>
                           </a:solidFill>
@@ -20500,7 +20717,7 @@
                     <a:lstStyle/>
                     <a:p>
                       <a:r>
-                        <a:rPr sz="1600" i="0" b="0">
+                        <a:rPr sz="1100" i="0" b="0">
                           <a:solidFill>
                             <a:srgbClr val="2B211C"/>
                           </a:solidFill>
@@ -20522,7 +20739,7 @@
                     <a:lstStyle/>
                     <a:p>
                       <a:r>
-                        <a:rPr sz="1600" i="0" b="0">
+                        <a:rPr sz="1100" i="0" b="0">
                           <a:solidFill>
                             <a:srgbClr val="2B211C"/>
                           </a:solidFill>
@@ -20539,14 +20756,14 @@
                   </a:tcPr>
                 </a:tc>
               </a:tr>
-              <a:tr h="411480">
+              <a:tr h="357862">
                 <a:tc>
                   <a:txBody>
                     <a:bodyPr/>
                     <a:lstStyle/>
                     <a:p>
                       <a:r>
-                        <a:rPr sz="1600" i="0" b="1">
+                        <a:rPr sz="1100" i="0" b="1">
                           <a:solidFill>
                             <a:srgbClr val="2B211C"/>
                           </a:solidFill>
@@ -20558,7 +20775,7 @@
                   </a:txBody>
                   <a:tcPr marL="109728" marR="109728" marT="45720" marB="45720" anchor="ctr">
                     <a:solidFill>
-                      <a:srgbClr val="FBF3EE"/>
+                      <a:srgbClr val="FAF4F2"/>
                     </a:solidFill>
                   </a:tcPr>
                 </a:tc>
@@ -20568,7 +20785,7 @@
                     <a:lstStyle/>
                     <a:p>
                       <a:r>
-                        <a:rPr sz="1600" i="0" b="0">
+                        <a:rPr sz="1100" i="0" b="0">
                           <a:solidFill>
                             <a:srgbClr val="2B211C"/>
                           </a:solidFill>
@@ -20580,7 +20797,7 @@
                   </a:txBody>
                   <a:tcPr marL="109728" marR="109728" marT="45720" marB="45720" anchor="ctr">
                     <a:solidFill>
-                      <a:srgbClr val="FBF3EE"/>
+                      <a:srgbClr val="FAF4F2"/>
                     </a:solidFill>
                   </a:tcPr>
                 </a:tc>
@@ -20590,7 +20807,7 @@
                     <a:lstStyle/>
                     <a:p>
                       <a:r>
-                        <a:rPr sz="1600" i="0" b="0">
+                        <a:rPr sz="1100" i="0" b="0">
                           <a:solidFill>
                             <a:srgbClr val="2B211C"/>
                           </a:solidFill>
@@ -20602,7 +20819,7 @@
                   </a:txBody>
                   <a:tcPr marL="109728" marR="109728" marT="45720" marB="45720" anchor="ctr">
                     <a:solidFill>
-                      <a:srgbClr val="FBF3EE"/>
+                      <a:srgbClr val="FAF4F2"/>
                     </a:solidFill>
                   </a:tcPr>
                 </a:tc>
@@ -20612,7 +20829,7 @@
                     <a:lstStyle/>
                     <a:p>
                       <a:r>
-                        <a:rPr sz="1600" i="0" b="0">
+                        <a:rPr sz="1100" i="0" b="0">
                           <a:solidFill>
                             <a:srgbClr val="2B211C"/>
                           </a:solidFill>
@@ -20624,7 +20841,7 @@
                   </a:txBody>
                   <a:tcPr marL="109728" marR="109728" marT="45720" marB="45720" anchor="ctr">
                     <a:solidFill>
-                      <a:srgbClr val="FBF3EE"/>
+                      <a:srgbClr val="FAF4F2"/>
                     </a:solidFill>
                   </a:tcPr>
                 </a:tc>
@@ -20634,7 +20851,7 @@
                     <a:lstStyle/>
                     <a:p>
                       <a:r>
-                        <a:rPr sz="1600" i="0" b="0">
+                        <a:rPr sz="1100" i="0" b="0">
                           <a:solidFill>
                             <a:srgbClr val="2B211C"/>
                           </a:solidFill>
@@ -20646,7 +20863,7 @@
                   </a:txBody>
                   <a:tcPr marL="109728" marR="109728" marT="45720" marB="45720" anchor="ctr">
                     <a:solidFill>
-                      <a:srgbClr val="FBF3EE"/>
+                      <a:srgbClr val="FAF4F2"/>
                     </a:solidFill>
                   </a:tcPr>
                 </a:tc>
@@ -20718,7 +20935,7 @@
           </a:fontRef>
         </p:style>
         <p:txBody>
-          <a:bodyPr rtlCol="0" anchor="ctr" lIns="0" rIns="0"/>
+          <a:bodyPr rtlCol="0" anchor="ctr" lIns="0" rIns="0" tIns="0" bIns="0"/>
           <a:lstStyle/>
           <a:p>
             <a:pPr algn="ctr"/>
@@ -20895,17 +21112,83 @@
           </a:prstGeom>
         </p:spPr>
       </p:pic>
+      <p:sp>
+        <p:nvSpPr>
+          <p:cNvPr id="8" name="TextBox 7"/>
+          <p:cNvSpPr txBox="1"/>
+          <p:nvPr/>
+        </p:nvSpPr>
+        <p:spPr>
+          <a:xfrm>
+            <a:off x="548640" y="1554480"/>
+            <a:ext cx="11094415" cy="1092708"/>
+          </a:xfrm>
+          <a:prstGeom prst="rect">
+            <a:avLst/>
+          </a:prstGeom>
+          <a:noFill/>
+        </p:spPr>
+        <p:txBody>
+          <a:bodyPr wrap="square" anchor="t" lIns="0" rIns="0" tIns="0" bIns="0">
+            <a:spAutoFit/>
+          </a:bodyPr>
+          <a:lstStyle/>
+          <a:p>
+            <a:pPr>
+              <a:spcAft>
+                <a:spcPts val="800"/>
+              </a:spcAft>
+            </a:pPr>
+            <a:r>
+              <a:rPr sz="1800" i="0" b="1">
+                <a:solidFill>
+                  <a:srgbClr val="2B211C"/>
+                </a:solidFill>
+                <a:latin typeface="Calibri"/>
+              </a:rPr>
+              <a:t>Worked example.</a:t>
+            </a:r>
+            <a:r>
+              <a:rPr sz="1800" i="0" b="0">
+                <a:solidFill>
+                  <a:srgbClr val="2B211C"/>
+                </a:solidFill>
+                <a:latin typeface="Calibri"/>
+              </a:rPr>
+              <a:t> A man starts enalapril and, two weeks later, develops a dry cough. Scores: Q1 yes (+1); Q2 yes (+2); Q3 the cough stops after enalapril is stopped (+1); Q4 not rechallenged (0); Q5 no other cause (+2); Q6-Q10 not done or not known (0). Total </a:t>
+            </a:r>
+            <a:r>
+              <a:rPr sz="1800" i="0" b="1">
+                <a:solidFill>
+                  <a:srgbClr val="2B211C"/>
+                </a:solidFill>
+                <a:latin typeface="Calibri"/>
+              </a:rPr>
+              <a:t>6 = probable</a:t>
+            </a:r>
+            <a:r>
+              <a:rPr sz="1800" i="0" b="0">
+                <a:solidFill>
+                  <a:srgbClr val="2B211C"/>
+                </a:solidFill>
+                <a:latin typeface="Calibri"/>
+              </a:rPr>
+              <a:t>.</a:t>
+            </a:r>
+          </a:p>
+        </p:txBody>
+      </p:sp>
       <p:graphicFrame>
         <p:nvGraphicFramePr>
-          <p:cNvPr id="8" name="Table 7"/>
+          <p:cNvPr id="9" name="Table 8"/>
           <p:cNvGraphicFramePr>
             <a:graphicFrameLocks noGrp="1"/>
           </p:cNvGraphicFramePr>
           <p:nvPr/>
         </p:nvGraphicFramePr>
         <p:xfrm>
-          <a:off x="548640" y="1600200"/>
-          <a:ext cx="11094414" cy="3886200"/>
+          <a:off x="548640" y="2830068"/>
+          <a:ext cx="11094414" cy="3200400"/>
         </p:xfrm>
         <a:graphic>
           <a:graphicData uri="http://schemas.openxmlformats.org/drawingml/2006/table">
@@ -20917,7 +21200,7 @@
                 <a:gridCol w="6022682"/>
                 <a:gridCol w="5071732"/>
               </a:tblGrid>
-              <a:tr h="777240">
+              <a:tr h="640080">
                 <a:tc>
                   <a:txBody>
                     <a:bodyPr/>
@@ -20963,7 +21246,7 @@
                   </a:tcPr>
                 </a:tc>
               </a:tr>
-              <a:tr h="777240">
+              <a:tr h="640080">
                 <a:tc>
                   <a:txBody>
                     <a:bodyPr/>
@@ -21009,7 +21292,7 @@
                   </a:tcPr>
                 </a:tc>
               </a:tr>
-              <a:tr h="777240">
+              <a:tr h="640080">
                 <a:tc>
                   <a:txBody>
                     <a:bodyPr/>
@@ -21028,7 +21311,7 @@
                   </a:txBody>
                   <a:tcPr marL="109728" marR="109728" marT="45720" marB="45720" anchor="ctr">
                     <a:solidFill>
-                      <a:srgbClr val="FBF3EE"/>
+                      <a:srgbClr val="FAF4F2"/>
                     </a:solidFill>
                   </a:tcPr>
                 </a:tc>
@@ -21050,12 +21333,12 @@
                   </a:txBody>
                   <a:tcPr marL="109728" marR="109728" marT="45720" marB="45720" anchor="ctr">
                     <a:solidFill>
-                      <a:srgbClr val="FBF3EE"/>
+                      <a:srgbClr val="FAF4F2"/>
                     </a:solidFill>
                   </a:tcPr>
                 </a:tc>
               </a:tr>
-              <a:tr h="777240">
+              <a:tr h="640080">
                 <a:tc>
                   <a:txBody>
                     <a:bodyPr/>
@@ -21101,7 +21384,7 @@
                   </a:tcPr>
                 </a:tc>
               </a:tr>
-              <a:tr h="777240">
+              <a:tr h="640080">
                 <a:tc>
                   <a:txBody>
                     <a:bodyPr/>
@@ -21120,7 +21403,7 @@
                   </a:txBody>
                   <a:tcPr marL="109728" marR="109728" marT="45720" marB="45720" anchor="ctr">
                     <a:solidFill>
-                      <a:srgbClr val="FBF3EE"/>
+                      <a:srgbClr val="FAF4F2"/>
                     </a:solidFill>
                   </a:tcPr>
                 </a:tc>
@@ -21142,7 +21425,7 @@
                   </a:txBody>
                   <a:tcPr marL="109728" marR="109728" marT="45720" marB="45720" anchor="ctr">
                     <a:solidFill>
-                      <a:srgbClr val="FBF3EE"/>
+                      <a:srgbClr val="FAF4F2"/>
                     </a:solidFill>
                   </a:tcPr>
                 </a:tc>
@@ -21214,7 +21497,7 @@
           </a:fontRef>
         </p:style>
         <p:txBody>
-          <a:bodyPr rtlCol="0" anchor="ctr" lIns="0" rIns="0"/>
+          <a:bodyPr rtlCol="0" anchor="ctr" lIns="0" rIns="0" tIns="0" bIns="0"/>
           <a:lstStyle/>
           <a:p>
             <a:pPr algn="ctr"/>
@@ -21408,7 +21691,7 @@
             </a:avLst>
           </a:prstGeom>
           <a:solidFill>
-            <a:srgbClr val="FBF3EE"/>
+            <a:srgbClr val="F6E5DE"/>
           </a:solidFill>
           <a:ln>
             <a:noFill/>
@@ -21481,7 +21764,7 @@
           <a:p>
             <a:pPr algn="ctr"/>
             <a:r>
-              <a:rPr sz="1050" i="0" b="1" spc="100">
+              <a:rPr sz="1050" i="0" b="1">
                 <a:solidFill>
                   <a:srgbClr val="FFFFFF"/>
                 </a:solidFill>
@@ -21589,7 +21872,7 @@
           </a:fontRef>
         </p:style>
         <p:txBody>
-          <a:bodyPr rtlCol="0" anchor="ctr" lIns="0" rIns="0"/>
+          <a:bodyPr rtlCol="0" anchor="ctr" lIns="0" rIns="0" tIns="0" bIns="0"/>
           <a:lstStyle/>
           <a:p>
             <a:pPr algn="ctr"/>
@@ -21766,17 +22049,99 @@
           </a:prstGeom>
         </p:spPr>
       </p:pic>
+      <p:sp>
+        <p:nvSpPr>
+          <p:cNvPr id="8" name="TextBox 7"/>
+          <p:cNvSpPr txBox="1"/>
+          <p:nvPr/>
+        </p:nvSpPr>
+        <p:spPr>
+          <a:xfrm>
+            <a:off x="548640" y="1554480"/>
+            <a:ext cx="11094415" cy="905256"/>
+          </a:xfrm>
+          <a:prstGeom prst="rect">
+            <a:avLst/>
+          </a:prstGeom>
+          <a:noFill/>
+        </p:spPr>
+        <p:txBody>
+          <a:bodyPr wrap="square" anchor="t" lIns="0" rIns="0" tIns="0" bIns="0">
+            <a:spAutoFit/>
+          </a:bodyPr>
+          <a:lstStyle/>
+          <a:p>
+            <a:pPr>
+              <a:spcAft>
+                <a:spcPts val="800"/>
+              </a:spcAft>
+            </a:pPr>
+            <a:r>
+              <a:rPr sz="1800" i="0" b="0">
+                <a:solidFill>
+                  <a:srgbClr val="2B211C"/>
+                </a:solidFill>
+                <a:latin typeface="Calibri"/>
+              </a:rPr>
+              <a:t>These two words sound alike but mean different things.</a:t>
+            </a:r>
+          </a:p>
+          <a:p>
+            <a:pPr>
+              <a:spcAft>
+                <a:spcPts val="800"/>
+              </a:spcAft>
+            </a:pPr>
+            <a:r>
+              <a:rPr sz="1800" i="0" b="1">
+                <a:solidFill>
+                  <a:srgbClr val="2B211C"/>
+                </a:solidFill>
+                <a:latin typeface="Calibri"/>
+              </a:rPr>
+              <a:t>Severity</a:t>
+            </a:r>
+            <a:r>
+              <a:rPr sz="1800" i="0" b="0">
+                <a:solidFill>
+                  <a:srgbClr val="2B211C"/>
+                </a:solidFill>
+                <a:latin typeface="Calibri"/>
+              </a:rPr>
+              <a:t> describes the </a:t>
+            </a:r>
+            <a:r>
+              <a:rPr sz="1800" i="0" b="1">
+                <a:solidFill>
+                  <a:srgbClr val="2B211C"/>
+                </a:solidFill>
+                <a:latin typeface="Calibri"/>
+              </a:rPr>
+              <a:t>intensity</a:t>
+            </a:r>
+            <a:r>
+              <a:rPr sz="1800" i="0" b="0">
+                <a:solidFill>
+                  <a:srgbClr val="2B211C"/>
+                </a:solidFill>
+                <a:latin typeface="Calibri"/>
+              </a:rPr>
+              <a:t> of the reaction:</a:t>
+            </a:r>
+          </a:p>
+        </p:txBody>
+      </p:sp>
       <p:graphicFrame>
         <p:nvGraphicFramePr>
-          <p:cNvPr id="8" name="Table 7"/>
+          <p:cNvPr id="9" name="Table 8"/>
           <p:cNvGraphicFramePr>
             <a:graphicFrameLocks noGrp="1"/>
           </p:cNvGraphicFramePr>
           <p:nvPr/>
         </p:nvGraphicFramePr>
         <p:xfrm>
-          <a:off x="548640" y="1600200"/>
-          <a:ext cx="11094414" cy="3108960"/>
+          <a:off x="548640" y="2642615"/>
+          <a:ext cx="11094414" cy="2560320"/>
         </p:xfrm>
         <a:graphic>
           <a:graphicData uri="http://schemas.openxmlformats.org/drawingml/2006/table">
@@ -21788,7 +22153,7 @@
                 <a:gridCol w="2113221"/>
                 <a:gridCol w="8981193"/>
               </a:tblGrid>
-              <a:tr h="777240">
+              <a:tr h="640080">
                 <a:tc>
                   <a:txBody>
                     <a:bodyPr/>
@@ -21834,7 +22199,7 @@
                   </a:tcPr>
                 </a:tc>
               </a:tr>
-              <a:tr h="777240">
+              <a:tr h="640080">
                 <a:tc>
                   <a:txBody>
                     <a:bodyPr/>
@@ -21880,7 +22245,7 @@
                   </a:tcPr>
                 </a:tc>
               </a:tr>
-              <a:tr h="777240">
+              <a:tr h="640080">
                 <a:tc>
                   <a:txBody>
                     <a:bodyPr/>
@@ -21899,7 +22264,7 @@
                   </a:txBody>
                   <a:tcPr marL="109728" marR="109728" marT="45720" marB="45720" anchor="ctr">
                     <a:solidFill>
-                      <a:srgbClr val="FBF3EE"/>
+                      <a:srgbClr val="FAF4F2"/>
                     </a:solidFill>
                   </a:tcPr>
                 </a:tc>
@@ -21921,12 +22286,12 @@
                   </a:txBody>
                   <a:tcPr marL="109728" marR="109728" marT="45720" marB="45720" anchor="ctr">
                     <a:solidFill>
-                      <a:srgbClr val="FBF3EE"/>
+                      <a:srgbClr val="FAF4F2"/>
                     </a:solidFill>
                   </a:tcPr>
                 </a:tc>
               </a:tr>
-              <a:tr h="777240">
+              <a:tr h="640080">
                 <a:tc>
                   <a:txBody>
                     <a:bodyPr/>

</xml_diff>